<commit_message>
Presentation: full speaker-note scripts (EN + Hebrew) and key equations
- Rewrote every slide's speaker notes into a first-person, student-voice
  script that explains each concept in plain words (TF-IDF, n-grams,
  logistic regression, recall/precision/F1/MCC/AUC, Spearman, VIF,
  Mann-Whitney, homoglyph, normalisation, certificate/UTS-39, monotone
  model, dilution, concept drift, OOV, poisoning, LLM-as-judge, etc.)
- Added a Hebrew translation under every note
- Added equations to slides: TF-IDF and logistic regression (slide 5),
  F1 and MCC (slide 10)
</commit_message>
<xml_diff>
--- a/presentation/PhishFusion_presentation_dark.pptx
+++ b/presentation/PhishFusion_presentation_dark.pptx
@@ -4598,7 +4598,9 @@
           <a:p>
             <a:r>
               <a:rPr lang="en-US" dirty="0"/>
-              <a:t>Open here. One line: I built the text-only half of a phishing detector — it reads just the words of an email and decides phishing or legitimate. But the real work isn't the score. It's showing that a near-perfect score is fragile, attacking my own model the way a real adversary would, and hardening it until parts are provable. My partner Gilad builds the links/sender half; together they fuse.</a:t>
+              <a:t>Hi everyone, I'm Lia. This is PhishFusion, and I built one half of it — the content detector. In simple words: it's a model that reads only the words of an email, the subject and the body, and decides whether it's phishing or a legitimate email. Just so we share the same definition: phishing is when an attacker pretends to be someone you trust — your bank, your IT department — to get you to click a link or hand over a password. My partner Gilad built the other half, which reads the links and the sender address. The thing I care about most in this project is this: getting a high score on clean data is easy. The real question is whether the model survives a real attacker who tries to fool it on purpose. So most of this talk is me attacking my own model and then fixing it — until some of the defences are mathematically guaranteed, not just 'it worked on my tests.'
+— — —  עברית  — — —
+שלום לכולם, אני ליה. זה הפרויקט PhishFusion, ואני בניתי חצי ממנו — גלאי התוכן. במילים פשוטות: זה מודל שקורא רק את הטקסט של המייל, הנושא והגוף, ומחליט אם זה פישינג או מייל לגיטימי. רק שיהיה לנו אותו מושג: פישינג זה כשתוקף מתחזה למישהו שאתם סומכים עליו — הבנק, מחלקת המחשוב — כדי שתלחצו על קישור או תמסרו סיסמה. השותף שלי גלעד בנה את החצי השני, שקורא את הקישורים ואת כתובת השולח. הדבר שהכי חשוב לי בפרויקט: לקבל ציון גבוה על דאטה נקי זה קל. השאלה האמיתית היא אם המודל שורד תוקף אמיתי שמנסה לרמות אותו בכוונה. אז רוב ההרצאה היא שאני תוקפת את המודל שלי ואז מתקנת אותו — עד שחלק מההגנות מובטחות מתמטית, ולא רק 'זה עבד לי בבדיקות'.</a:t>
             </a:r>
             <a:endParaRPr lang="en-US" dirty="0"/>
           </a:p>
@@ -4686,7 +4688,9 @@
           <a:p>
             <a:r>
               <a:rPr lang="en-US" dirty="0"/>
-              <a:t>On the clean test set the model is almost perfect: F1 0.998, and only 8 mistakes out of over five thousand emails — the confusion matrix on the right shows how few. Here's the important bit: this is the warning, not the victory. A near-perfect score on clean, single-source data does NOT prove the detector survives the real world. So the rest of the project asks the hard questions — does it survive obfuscation, an adaptive attacker, a different inbox, and the passage of time? From here I attack my own model on purpose.</a:t>
+              <a:t>Here are the results on the clean test set, and the numbers are almost perfect. Let me quickly define them since I'll use them all talk. Recall is the share of real phishing the model catches. Precision is, out of everything it flagged, how much was truly phishing. F1 combines those two into one number — the formula's at the bottom — and 0.998 out of 1 is basically perfect. MCC, 0.997, is another combined score that's honest even when one class is much bigger than the other; it runs from minus 1 to plus 1, where 1 is perfect. AUC of 1.00 means if you hand it one phishing and one legit email, it ranks them correctly essentially every time. The grid on the right is a confusion matrix — it just splits every decision into four boxes: correctly caught, correctly passed, false alarms, and missed. Only 8 mistakes out of over five thousand emails. Now the most important sentence of the whole talk: this is a WARNING, not a victory. A near-perfect score on clean, single-source data does not prove the detector works in the real world. So from here on, I deliberately attack my own model — obfuscation, a smart attacker, a different inbox, and the passage of time.
+— — —  עברית  — — —
+הנה התוצאות על סט המבחן הנקי, והמספרים כמעט מושלמים. אגדיר אותם מהר כי אשתמש בהם לאורך כל ההרצאה. Recall (היזכרות) זה החלק מהפישינג האמיתי שהמודל תופס. Precision (דיוק) זה, מכל מה שהוא סימן, כמה באמת היה פישינג. F1 משלב את שניהם למספר אחד — הנוסחה למטה — ו-0.998 מתוך 1 זה בעצם מושלם. MCC, 0.997, הוא ציון משולב נוסף שכן ומאוזן גם כשמחלקה אחת הרבה יותר גדולה מהשנייה; הוא נע ממינוס 1 עד פלוס 1, כש-1 זה מושלם. AUC של 1.00 אומר שאם תיתן לו מייל פישינג אחד ומייל לגיטימי אחד, הוא ידרג אותם נכון כמעט תמיד. הרשת מימין היא מטריצת בלבול (confusion matrix) — היא פשוט מחלקת כל החלטה לארבע קופסאות: נתפס נכון, עבר נכון, אזעקות שווא, ופספוסים. רק 8 טעויות מתוך יותר מחמשת אלפים מיילים. עכשיו המשפט הכי חשוב בכל ההרצאה: זו אזהרה, לא ניצחון. ציון כמעט מושלם על דאטה נקי ממקור יחיד לא מוכיח שהגלאי עובד בעולם האמיתי. אז מכאן והלאה, אני תוקפת בכוונה את המודל שלי — ערפול, תוקף חכם, תיבת דואר אחרת, וחלוף הזמן.</a:t>
             </a:r>
             <a:endParaRPr lang="en-US" dirty="0"/>
           </a:p>
@@ -4774,7 +4778,9 @@
           <a:p>
             <a:r>
               <a:rPr lang="en-US" dirty="0"/>
-              <a:t>This is the pivot of the whole talk. Up to now I've built a detector that looks near-perfect. From here I deliberately switch sides and attack my own model the way a real adversary would, then fix each hole and immediately attack the fix. So for the next few slides, watch for the same three-part structure every time: the attack, the fix, and the result in numbers. Remember — the broken versions are not failures. Finding and closing them is exactly the point.</a:t>
+              <a:t>This is the turning point of the talk, so I pause here for a second. Everything up to now built a detector that looks near-perfect. From here I switch sides: I become the attacker and try to fool my own model the way a real criminal would, and then I fix each hole and attack the fix again. So for the next several slides, watch for the same three-part structure every single time: THE ATTACK — what the trick is; THE FIX — what I did about it; and THE RESULT — the numbers before and after. And please keep in mind: the broken versions I'm about to show are not failures. Finding them and closing them is exactly the point of the project.
+— — —  עברית  — — —
+זו נקודת המפנה של ההרצאה, אז אני עוצרת כאן לרגע. כל מה שעד עכשיו בנה גלאי שנראה כמעט מושלם. מכאן אני מחליפה צד: אני הופכת לתוקפת ומנסה לרמות את המודל שלי כמו שפושע אמיתי היה עושה, ואז מתקנת כל חור ותוקפת שוב את התיקון. אז בשקפים הבאים, שימו לב לאותו מבנה תלת-חלקי כל פעם מחדש: THE ATTACK — מה הטריק; THE FIX — מה עשיתי בנוגע אליו; ו-THE RESULT — המספרים לפני ואחרי. וזכרו בבקשה: הגרסאות השבורות שאני עומדת להראות הן לא כישלונות. למצוא אותן ולסגור אותן זו בדיוק מטרת הפרויקט.</a:t>
             </a:r>
             <a:endParaRPr lang="en-US" dirty="0"/>
           </a:p>
@@ -4862,7 +4868,9 @@
           <a:p>
             <a:r>
               <a:rPr lang="en-US" dirty="0"/>
-              <a:t>First attack — and it's nearly free for the attacker. I swap ordinary letters for Cyrillic look-alikes that are visually identical. A person reads 'Verify your account' unchanged, but the word-matching model sees brand-new unknown tokens, so the phishing words vanish. THE RESULT: on the word-only model, recall — the share of phishing it catches — drops from 0.99 to 0.71. This is the imperceptible attack the literature warns about (Eger 2019, Boucher 2022), and it costs the attacker almost nothing.</a:t>
+              <a:t>My first attack, and what makes it scary is that it's almost free for the attacker. THE ATTACK: I take the phishing words and swap ordinary Latin letters for Cyrillic look-alikes — letters from the Russian alphabet that are drawn identically. You can see it: 'Verify your account', but the coloured letters are secretly Cyrillic. This is called a homoglyph attack. To a human it reads exactly the same. But remember my model matches words as exact strings of characters — so to it, this is a brand-new word it has never seen. The technical term is a 'token', which just means a unit the model counts, usually a word. The phishing words effectively vanish. THE RESULT: on the word-only model, recall — again, the share of phishing it catches — falls from 0.99 all the way to 0.71. So almost a third of phishing now slips through, from a change you literally cannot see. This is exactly the 'imperceptible' attack that papers by Eger and Boucher warn about.
+— — —  עברית  — — —
+המתקפה הראשונה שלי, ומה שמפחיד בה זה שהיא כמעט חינם לתוקף. THE ATTACK: אני לוקחת את מילות הפישינג ומחליפה אותיות לטיניות רגילות בכפילות קיריליות — אותיות מהאלפבית הרוסי שמצוירות בדיוק אותו דבר. אתם רואים: 'Verify your account', אבל האותיות הצבעוניות הן בסתר קיריליות. זה נקרא מתקפת הומוגליף (homoglyph). לאדם זה נקרא בדיוק אותו דבר. אבל תזכרו שהמודל שלי משווה מילים כמחרוזות תווים מדויקות — אז מבחינתו זו מילה חדשה לגמרי שהוא לא ראה מעולם. המונח הטכני הוא 'token', שפשוט אומר יחידה שהמודל סופר, בדרך כלל מילה. מילות הפישינג בעצם נעלמות. THE RESULT: במודל שמבוסס-מילים בלבד, ה-recall — שוב, החלק מהפישינג שהוא תופס — יורד מ-0.99 עד ל-0.71. כלומר כמעט שליש מהפישינג עכשיו חומק, משינוי שממש אי אפשר לראות. זו בדיוק המתקפה ה'בלתי-נראית' שמאמרים של אגר ובושה מזהירים ממנה.</a:t>
             </a:r>
             <a:endParaRPr lang="en-US" dirty="0"/>
           </a:p>
@@ -4950,7 +4958,9 @@
           <a:p>
             <a:r>
               <a:rPr lang="en-US" dirty="0"/>
-              <a:t>The fix, shown against the attack. Grey is undefended. THE FIX — teal — is normalisation: I fold look-alike characters back to plain letters before classifying, and add character n-grams. THE RESULT: recall jumps from 0.71 back to ~0.99, and crucially it also repairs a DIFFERENT attack it was never designed for, full-width letters, because the folding is general. Amber is adversarial training — retraining on attacked examples; it's perfect on the family it saw but weaker on the unseen full-width one at 0.78. THE LESSON: a principled input defence generalises; a memorised one doesn't. Used together they cover every family.</a:t>
+              <a:t>Now I fix it, and I compare two different defences. The grey bars are the undefended model, for reference. THE FIX, the teal bars, is called normalisation. In plain words: before the model reads the email, I run a cleaning step that folds every look-alike character back to its plain letter — the Cyrillic 'е' becomes a normal 'e' again. I also add the character n-grams from before. THE RESULT: recall jumps from 0.71 back to about 0.99. And here's the beautiful part — it also fixes a completely DIFFERENT attack I never designed it for, called full-width letters, because the folding rule is general, not a specific patch. The amber bars are a second approach, adversarial training — that means I retrain the model on examples that are already attacked, so it learns them. It's perfect on the attack it saw, but weaker, 0.78, on the unseen one. THE LESSON, and it's a real research point: a principled, general defence transfers to new attacks; a memorised one only knows what it was shown. So I use both together, and stacked they cover everything.
+— — —  עברית  — — —
+עכשיו אני מתקנת, ואני משווה שתי הגנות שונות. העמודות האפורות הן המודל הלא-מוגן, לצורך השוואה. THE FIX, העמודות בטורקיז, נקראת נורמליזציה (normalisation). במילים פשוטות: לפני שהמודל קורא את המייל, אני מריצה שלב ניקוי שמחזיר כל תו כפילות לאות הרגילה שלו — ה-'е' הקירילית חוזרת להיות 'e' רגילה. אני גם מוסיפה את ה-character n-grams מקודם. THE RESULT: ה-recall קופץ מ-0.71 בחזרה לבערך 0.99. והנה החלק היפה — זה גם מתקן מתקפה אחרת לגמרי שלא תכננתי בשבילה, שנקראת אותיות ברוחב מלא, כי כלל הקיפול הוא כללי, לא טלאי ספציפי. העמודות בענבר הן גישה שנייה, אימון יריב (adversarial training) — כלומר אני מאמנת מחדש את המודל על דוגמאות שכבר מותקפות, כדי שילמד אותן. זה מושלם על המתקפה שהוא ראה, אבל חלש יותר, 0.78, על זו שלא ראה. THE LESSON, וזו נקודה מחקרית אמיתית: הגנה עקרונית וכללית עוברת למתקפות חדשות; הגנה משוננת יודעת רק את מה שהראו לה. אז אני משתמשת בשתיהן יחד, ובשילוב הן מכסות הכל.</a:t>
             </a:r>
             <a:endParaRPr lang="en-US" dirty="0"/>
           </a:p>
@@ -5038,7 +5048,9 @@
           <a:p>
             <a:r>
               <a:rPr lang="en-US" dirty="0"/>
-              <a:t>So far attacks changed letters at random. THE ATTACK now is smarter: it spends its budget only on the words the model relies on most, and uses look-alike letters my hand-made cleaning list happens to miss — the DeepWordBug / TextBugger family. THE RESULT: same effort, 8 edits, but targeted edits cut recall to 0.74 versus 0.98 for random. A typical email flips after just 9 invisible edits, about a quarter of its letters. And it lowers the ceiling of even my fully-defended model to 0.88. This is the honest 'no silver bullet' moment — a capable adversary found the gap.</a:t>
+              <a:t>Now I make the attacker smarter, because a real criminal wouldn't attack randomly. THE ATTACK: instead of changing random letters, the attacker first works out which words my model relies on most — the highest-weight words — and only disguises those. This is called an importance-guided or adaptive attack, and it's a known family with names like DeepWordBug and TextBugger. It also uses look-alike characters that my hand-made cleaning list happened to miss — because my list was incomplete. THE RESULT: with the exact same budget, 8 edits, aiming them cleverly drops recall to 0.74, versus 0.98 when the same 8 edits are random. A typical email flips from 'phishing' to 'safe' after only 9 invisible edits — about a quarter of its letters. And even my fully-defended model gets pulled down to 0.88. This is the honest 'there is no silver bullet' moment: a capable, thoughtful attacker found the gap. Which sets up the next slide, where I close it for good.
+— — —  עברית  — — —
+עכשיו אני הופכת את התוקף לחכם יותר, כי פושע אמיתי לא היה תוקף באקראי. THE ATTACK: במקום לשנות אותיות אקראיות, התוקף קודם מגלה על אילו מילים המודל שלי הכי נשען — המילים עם המשקל הגבוה ביותר — ומחפש רק אותן. זה נקרא מתקפה מונחית-חשיבות או אדפטיבית, וזו משפחה מוכרת עם שמות כמו DeepWordBug ו-TextBugger. היא גם משתמשת בתווי כפילות שהרשימה הידנית שלי פספסה — כי הרשימה שלי לא הייתה שלמה. THE RESULT: עם אותו תקציב בדיוק, 8 שינויים, כיוון חכם שלהם מוריד את ה-recall ל-0.74, לעומת 0.98 כשאותם 8 שינויים אקראיים. מייל טיפוסי מתהפך מ'פישינג' ל'בטוח' אחרי רק 9 שינויים בלתי-נראים — בערך רבע מהאותיות שלו. ואפילו המודל המוגן לגמרי שלי נמשך למטה ל-0.88. זה הרגע הכן של 'אין פתרון קסם': תוקף מוכשר וחושב מצא את הפרצה. וזה מכין את השקף הבא, שבו אני סוגרת אותה סופית.</a:t>
             </a:r>
             <a:endParaRPr lang="en-US" dirty="0"/>
           </a:p>
@@ -5126,7 +5138,9 @@
           <a:p>
             <a:r>
               <a:rPr lang="en-US" dirty="0"/>
-              <a:t>The fix, and it comes with a proof. THE FIX: I swap my hand-made list of look-alike letters for the FULL official list — UTS #39, the same one browsers use to catch fake web addresses. The letters the attacker slipped through are all on it. THE RESULT: recall against the smart attacker goes back to 0.998. And here's the guarantee — the big 100% — even in the worst case, cleaning the attacked email gives back exactly the original text for 100% of phishing emails, 0% with the old list, so the decision provably cannot change. This closes the cheap letter-attack front for good and forces the attacker onto something harder.</a:t>
+              <a:t>Here's the fix, and this one is special because it comes with a mathematical guarantee. THE FIX: the problem before was that my hand-made list of look-alike letters was incomplete. So I replace it with the FULL official list — it's a real published standard called Unicode UTS #39, the exact same list web browsers use to catch fake website addresses. Every letter the attacker sneaked through is on that list. THE RESULT: recall against the smart attacker goes right back to 0.998. And now the important word — the big 100% on the left is a certificate. A certificate, in this context, means a proof: not 'it worked in my tests', but 'it is mathematically impossible for this to fail'. Specifically, I can prove that after cleaning, the attacked email turns back into exactly the original text for 100% of phishing emails — it was 0% with my old list. So the model's decision provably cannot change, no matter which look-alike letters the attacker picks. This shuts the cheap letter-attack door for good and forces the attacker to try something genuinely harder.
+— — —  עברית  — — —
+הנה התיקון, וזה מיוחד כי הוא מגיע עם הבטחה מתמטית. THE FIX: הבעיה קודם הייתה שהרשימה הידנית שלי של אותיות דומות הייתה חלקית. אז אני מחליפה אותה ברשימה הרשמית המלאה — זה תקן מפורסם אמיתי שנקרא Unicode UTS #39, בדיוק אותה רשימה שדפדפני אינטרנט משתמשים בה כדי לתפוס כתובות אתרים מזויפות. כל אות שהתוקף הבריח נמצאת ברשימה הזאת. THE RESULT: ה-recall מול התוקף החכם חוזר ישר ל-0.998. ועכשיו המילה החשובה — ה-100% הגדול משמאל הוא תעודה (certificate). תעודה, בהקשר הזה, אומרת הוכחה: לא 'זה עבד בבדיקות שלי', אלא 'מתמטית בלתי אפשרי שזה ייכשל'. ספציפית, אני יכולה להוכיח שאחרי הניקוי, המייל המותקף חוזר להיות בדיוק הטקסט המקורי עבור 100% ממיילי הפישינג — זה היה 0% עם הרשימה הישנה. אז ההחלטה של המודל מוכחת שלא יכולה להשתנות, לא משנה אילו אותיות דומות התוקף בוחר. זה סוגר את דלת מתקפת-האותיות הזולה לתמיד ומכריח את התוקף לנסות משהו קשה באמת.</a:t>
             </a:r>
             <a:endParaRPr lang="en-US" dirty="0"/>
           </a:p>
@@ -5214,7 +5228,9 @@
           <a:p>
             <a:r>
               <a:rPr lang="en-US" dirty="0"/>
-              <a:t>With the letter tricks shut by proof, the attacker switches to whole words. THE ATTACK is the classic 'good-word attack' (Lowd &amp; Meek 2005): bury the scam under innocent-sounding filler. Because the model simply adds up word-evidence, enough legit words out-vote the scam. THE RESULT: recall collapses from 0.998 to 0.13, the red line. My letter-cleaner is useless here, it's the wrong defence for a new attack. This is a structural weakness of any linear bag-of-words model. The teal line is the fix, which is the next slide.</a:t>
+              <a:t>Since I closed the letter tricks with a proof, the attacker has to change strategy — and moves from letters to whole words. THE ATTACK is a classic one from a 2005 paper by Lowd and Meek called the 'good-word attack', or dilution. The idea: take the phishing email and pad it with lots of innocent, normal-sounding words — a paragraph of harmless text. Here's why it works, and it's a real weakness of my model. My model is what's called a bag-of-words: it basically adds up evidence word by word, and ignores order. So if you add enough innocent words, their combined 'this looks legit' vote out-weighs the few scam words, and the total tips over to 'safe'. THE RESULT, the red line: as I add more filler words, recall collapses from 0.998 all the way down to 0.13. And notice — my letter-cleaner from before does nothing here, because this is a totally different kind of attack. This is a structural weakness of any linear bag-of-words model, not a small bug. The teal line, which barely moves, is my fix — and that's the next slide.
+— — —  עברית  — — —
+מכיוון שסגרתי את טריקי-האותיות עם הוכחה, התוקף חייב לשנות אסטרטגיה — ועובר מאותיות למילים שלמות. THE ATTACK היא קלאסיקה ממאמר של Lowd ו-Meek מ-2005 שנקראת 'מתקפת מילים טובות' (good-word attack), או דילול. הרעיון: לקחת את מייל הפישינג ולמלא אותו בהמון מילים תמימות ונורמליות — פסקה של טקסט לא מזיק. הנה למה זה עובד, וזו חולשה אמיתית של המודל שלי. המודל שלי הוא מה שנקרא bag-of-words (שק של מילים): הוא בעצם מחבר ראיות מילה-מילה, ומתעלם מהסדר. אז אם מוסיפים מספיק מילים תמימות, ההצבעה המשולבת שלהן 'זה נראה לגיטימי' גוברת על מעט מילות ההונאה, והסך הכל נוטה ל'בטוח'. THE RESULT, הקו האדום: ככל שאני מוסיפה יותר מילות מילוי, ה-recall קורס מ-0.998 עד ל-0.13. ושימו לב — מנקה-האותיות מקודם לא עוזר כאן בכלל, כי זו מתקפה מסוג אחר לגמרי. זו חולשה מבנית של כל מודל bag-of-words לינארי, לא באג קטן. הקו הטורקיז, שכמעט לא זז, הוא התיקון שלי — וזה השקף הבא.</a:t>
             </a:r>
             <a:endParaRPr lang="en-US" dirty="0"/>
           </a:p>
@@ -5302,7 +5318,9 @@
           <a:p>
             <a:r>
               <a:rPr lang="en-US" dirty="0"/>
-              <a:t>The fix is a second guarantee. THE FIX: I build a model where every word can only add suspicion, never remove it. Then adding text can only push the score up — so padding provably cannot clear a scam. THE RESULT: I checked it directly — zero score-drops, and 100% of flagged phishing stays flagged even after adding 40, 100, or 300 words. The price is honesty: on clean data this one-way model scores 0.91 instead of 0.998, because it can only look for guilt, never innocence. So it's a guaranteed safety net running alongside the main model, not a replacement. That's now two whole attack classes — letters and word-padding — closed by proof.</a:t>
+              <a:t>The fix is my second guarantee, and the idea is quite elegant. THE FIX: I build a special version of the model that is 'one-way', or monotone. Normally, some words push the score toward phishing and some words push it toward safe. In the one-way model, I force every word's weight to be zero or positive — meaning a word can only ADD suspicion, it can never subtract it. The consequence is powerful: if adding text can only push the score up, then no amount of innocent filler can ever push it down below the line. So padding provably cannot un-flag a scam. THE RESULT: I tested it directly — zero cases where the score dropped, and 100% of flagged phishing stayed flagged even after adding 40, 100, even 300 words. But I'm honest about the price: on clean data this one-way model scores 0.91 instead of 0.998, because it lost the ability to use 'innocent' evidence — it can only look for guilt, never for innocence. So I don't replace my main model with it; I run it alongside as a guaranteed safety net. And that now makes two whole classes of attack — letter tricks and word-padding — closed by proof, not just by a better score.
+— — —  עברית  — — —
+התיקון הוא ההבטחה השנייה שלי, והרעיון די אלגנטי. THE FIX: אני בונה גרסה מיוחדת של המודל שהיא 'חד-כיוונית', או מונוטונית (monotone). בדרך כלל, חלק מהמילים דוחפות את הציון לכיוון פישינג וחלק דוחפות לכיוון בטוח. במודל החד-כיווני, אני מכריחה את המשקל של כל מילה להיות אפס או חיובי — כלומר מילה יכולה רק להוסיף חשד, לעולם לא להחסיר. התוצאה חזקה: אם הוספת טקסט יכולה רק לדחוף את הציון למעלה, אז שום כמות של מילוי תמים לא יכולה לדחוף אותו מתחת לקו. אז דילול מוכח שלא יכול לבטל סימון של הונאה. THE RESULT: בדקתי את זה ישירות — אפס מקרים שבהם הציון ירד, ו-100% מהפישינג המסומן נשאר מסומן גם אחרי הוספת 40, 100, ואפילו 300 מילים. אבל אני כנה לגבי המחיר: על דאטה נקי המודל החד-כיווני הזה מקבל 0.91 במקום 0.998, כי הוא איבד את היכולת להשתמש בראיות 'תמימות' — הוא יכול לחפש רק אשמה, לעולם לא חפות. אז אני לא מחליפה בו את המודל הראשי; אני מריצה אותו לצד, כרשת ביטחון מובטחת. וזה עכשיו הופך שתי מחלקות שלמות של מתקפות — טריקי-אותיות ומילוי-מילים — לסגורות בהוכחה, לא רק בציון טוב יותר.</a:t>
             </a:r>
             <a:endParaRPr lang="en-US" dirty="0"/>
           </a:p>
@@ -5390,7 +5408,9 @@
           <a:p>
             <a:r>
               <a:rPr lang="en-US" dirty="0"/>
-              <a:t>This one line is the whole story. Reading left to right: clean is perfect; the homoglyph attack drops it; normalisation restores it; the targeted attacker drops it again; the full official list restores it with a proof; then the word-dilution attack crushes it to 0.13; and the one-way model brings it back to 0.99 with a second proof. Every dip is an attacker getting smarter, every recovery is a defence, and two of those recoveries are guaranteed rather than just measured. The remaining open frontier is full semantic rewording — which needs the fusion.</a:t>
+              <a:t>This single line is the whole story of the project in one picture, so I take my time on it. Reading left to right, each point is recall: clean, the model is perfect; then the homoglyph letter-attack drops it; normalisation brings it back up; then the smart targeted attacker drops it again; the full official UTS-39 list brings it back, this time with a proof; then the word-dilution attack crushes it down to 0.13; and finally the one-way monotone model lifts it back up, with a second proof. So every dip is the attacker getting smarter, and every recovery is a defence I built. The key point: two of those recoveries — the ones marked as certificates — are not just 'it measured well', they are mathematically guaranteed. The one frontier still open on the far right is a full meaning-preserving rewrite of the email, and that's honestly why the content detector needs to be fused with Gilad's second signal.
+— — —  עברית  — — —
+הקו הבודד הזה הוא כל הסיפור של הפרויקט בתמונה אחת, אז אני לוקחת את הזמן עליו. קוראים משמאל לימין, כל נקודה היא recall: נקי, המודל מושלם; אז מתקפת האותיות הומוגליף מורידה אותו; נורמליזציה מחזירה אותו למעלה; אז התוקף החכם והממוקד מוריד אותו שוב; הרשימה הרשמית המלאה UTS-39 מחזירה אותו, הפעם עם הוכחה; אז מתקפת דילול-המילים מרסקת אותו ל-0.13; ולבסוף המודל החד-כיווני המונוטוני מרים אותו בחזרה, עם הוכחה שנייה. אז כל ירידה היא התוקף שנעשה חכם יותר, וכל התאוששות היא הגנה שבניתי. הנקודה המרכזית: שתיים מההתאוששויות האלה — אלה המסומנות כתעודות — הן לא רק 'זה נמדד טוב', הן מובטחות מתמטית. החזית האחת שעדיין פתוחה בקצה הימני היא כתיבה מחדש של המייל תוך שמירה על המשמעות, וזו בכנות הסיבה שגלאי התוכן צריך להתמזג עם האות השני של גלעד.</a:t>
             </a:r>
             <a:endParaRPr lang="en-US" dirty="0"/>
           </a:p>
@@ -5478,7 +5498,9 @@
           <a:p>
             <a:r>
               <a:rPr lang="en-US" dirty="0"/>
-              <a:t>This is the one-glance summary of the whole robustness study — the same story as the line chart before it, but as a table you can read row by row. Three attacks. Homoglyph, the invisible letter swap: recall 0.99 to 0.71, fixed by normalisation and character n-grams, back to 0.99. Targeted adaptive, aiming edits at the words the model trusts most: it dragged the defended model down to 0.88, closed by the full UTS-39 confusables list — back to 0.998, and certified. Dilution, padding the scam with innocent words: recall collapses 0.998 to 0.13, answered by the monotone one-way model with a floor of 0.87. The key line at the bottom: two of the three defences are guarantees, not just better numbers — look-alike letters and word-padding provably cannot flip a decision. That's the difference between 'it scored well against my attacks' and 'this class of attack is excluded by construction.'</a:t>
+              <a:t>This is the same story as the line before, but as a table you can read row by row — it's the one-glance summary of all my attacks and defences. Row one, Homoglyph, the invisible letter swap: recall fell 0.99 to 0.71, and normalisation plus character n-grams brought it back to 0.99. Row two, the Targeted adaptive attacker that aims at the most important words: it dragged even my defended model down to 0.88, and the full UTS-39 list brought it back to 0.998 — and that one is certified, proven. Row three, Dilution, padding the scam with innocent words: recall collapsed 0.998 to 0.13, and the one-way monotone model puts a guaranteed floor under it at 0.87. The line I most want you to take away is at the bottom: two of the three defences are guarantees, not just better numbers. Look-alike letters and word-padding provably cannot flip a decision. That's the real difference — between saying 'it scored well against the attacks I happened to try' and saying 'this entire class of attack is ruled out by design.'
+— — —  עברית  — — —
+זה אותו סיפור כמו הקו הקודם, אבל כטבלה שאפשר לקרוא שורה-שורה — זו התמצית במבט אחד של כל המתקפות וההגנות שלי. שורה ראשונה, הומוגליף, החלפת האותיות הבלתי-נראית: ה-recall ירד מ-0.99 ל-0.71, ונורמליזציה יחד עם character n-grams החזירו אותו ל-0.99. שורה שנייה, התוקף האדפטיבי הממוקד שמכוון למילים הכי חשובות: הוא גרר אפילו את המודל המוגן שלי ל-0.88, והרשימה המלאה UTS-39 החזירה אותו ל-0.998 — וזה מאושר בתעודה, מוכח. שורה שלישית, דילול, מילוי ההונאה במילים תמימות: ה-recall קרס מ-0.998 ל-0.13, והמודל החד-כיווני המונוטוני שם רצפה מובטחת מתחתיו ב-0.87. השורה שהכי חשוב לי שתיקחו נמצאת למטה: שתיים משלוש ההגנות הן הבטחות, לא רק מספרים טובים יותר. אותיות דומות ומילוי-מילים מוכחים שלא יכולים להפוך החלטה. זה ההבדל האמיתי — בין להגיד 'זה קיבל ציון טוב מול המתקפות שבמקרה ניסיתי' לבין 'כל המחלקה הזאת של מתקפות נשללת בתכנון'.</a:t>
             </a:r>
             <a:endParaRPr lang="en-US" dirty="0"/>
           </a:p>
@@ -5566,7 +5588,9 @@
           <a:p>
             <a:r>
               <a:rPr lang="en-US" dirty="0"/>
-              <a:t>Phishing is social engineering: it works on human trust, not code. The persuasion is carried by language, and it comes in a few recognisable flavours — pretending to be authority ('this is IT'), manufacturing urgency ('suspended in 30 minutes'), dangling a reward, or claiming everyone else already complied. That is exactly why an NLP model can catch it: the manipulation is in the words. But it also means the attacker fights back on the text — like 'verify' with a Cyrillic 'e': identical to us, a new unknown word to a word-matcher. Hold that example, it returns as the first attack.</a:t>
+              <a:t>So why can a model that only reads text catch phishing at all? Because phishing is what we call social engineering — it attacks the human, not the computer. It works by pushing emotional buttons, and those buttons live in the language. There are a few classic ones, and you can see them on the slide: authority — pretending to be your IT team; urgency — 'your account will be closed in 30 minutes'; reward — 'you won a prize'; and social proof — 'everyone else already did it.' Because the trick is in the words, a language model — that's what NLP means, a model that processes natural human text — can learn to spot it. But the same fact means the attacker can fight back by messing with the text. Look at the bottom: 'verify' written normally, and 'verify' where the 'e' is actually a Cyrillic letter from the Russian alphabet that looks identical. To us it's the same word; to a model that matches exact words, it's a brand-new word it has never seen. That's called a homoglyph, and it comes back as my very first attack.
+— — —  עברית  — — —
+אז למה מודל שקורא רק טקסט בכלל מסוגל לתפוס פישינג? כי פישינג הוא מה שנקרא הנדסה חברתית (social engineering) — הוא תוקף את האדם, לא את המחשב. הוא עובד על ידי לחיצה על כפתורים רגשיים, והכפתורים האלה נמצאים בשפה. יש כמה קלאסיים, ורואים אותם על השקף: סמכות — התחזות למחלקת המחשוב; דחיפות — 'החשבון שלך ייסגר בעוד 30 דקות'; פרס — 'זכית'; והוכחה חברתית — 'כולם כבר עשו את זה'. בגלל שהתרמית נמצאת במילים, מודל שפה — זה מה שאומר NLP, מודל שמעבד טקסט אנושי טבעי — יכול ללמוד לזהות אותה. אבל אותה עובדה אומרת שהתוקף יכול להילחם בחזרה דרך הטקסט. תראו למטה: 'verify' רגיל, ו-'verify' שבו האות e היא בעצם אות קירילית מהאלפבית הרוסי שנראית זהה. לנו זו אותה מילה; למודל שמשווה מילים מדויקות, זו מילה חדשה לגמרי שהוא לא ראה מעולם. זה נקרא הומוגליף (homoglyph), וזה חוזר בתור המתקפה הראשונה שלי.</a:t>
             </a:r>
             <a:endParaRPr lang="en-US" dirty="0"/>
           </a:p>
@@ -5654,7 +5678,9 @@
           <a:p>
             <a:r>
               <a:rPr lang="en-US" dirty="0"/>
-              <a:t>First honesty check: space. Trained on one source, tested on totally different collections, F1 falls from 0.998 to 0.37 — that's the real cost of distribution shift, and it's the honest number for the wild, not the flattering in-lab 0.998. But I diagnose it rather than just report it: the out-of-distribution AUC is still 0.78, so the ranking is fine and the model is only under-confident — re-thresholding recovers F1 to 0.75. What genuinely remains is a vocabulary gap: out-of-vocabulary words jump from 7% to 20%. So the headline 0.37 overstates it, but a real domain gap remains — which is the argument for retraining and for fusion.</a:t>
+              <a:t>Now two reality checks, because a lab score can be misleading. This first one is about space — a different inbox. So far I trained and tested on the same source. Here I train on my source but test on completely different email collections, and F1 falls hard, from 0.998 to 0.37. That gap is called distribution shift, or out-of-distribution — it just means the new data doesn't look like the data the model learned from. And 0.37 is the honest number for the messy real world, not the flattering 0.998 from the lab. But I don't just report the bad number — I diagnose it. The AUC, that ranking score, is still 0.78 on the new data, which tells me the model isn't broken, it's just set to the wrong sensitivity — it's under-confident. If I re-tune that one threshold, the decision line, F1 recovers to 0.75. What genuinely remains is a vocabulary gap: the share of words the model has never seen — 'out-of-vocabulary' — jumps from 7% to 20%. So the scary 0.37 overstates the damage, but a real gap remains — and that's exactly the argument for retraining on fresh mail and for fusing with Gilad.
+— — —  עברית  — — —
+עכשיו שתי בדיקות מציאות, כי ציון מעבדה יכול להטעות. הראשונה היא על מרחב — תיבת דואר אחרת. עד עכשיו אימנתי ובדקתי על אותו מקור. כאן אני מאמנת על המקור שלי אבל בודקת על אוספי מיילים שונים לגמרי, וה-F1 יורד חזק, מ-0.998 ל-0.37. הפער הזה נקרא הסחת התפלגות (distribution shift), או out-of-distribution — זה פשוט אומר שהדאטה החדש לא נראה כמו הדאטה שהמודל למד ממנו. ו-0.37 הוא המספר הכן לעולם האמיתי הבלגני, לא ה-0.998 המחמיא מהמעבדה. אבל אני לא רק מדווחת על המספר הרע — אני מאבחנת אותו. ה-AUC, ציון הדירוג, עדיין 0.78 על הדאטה החדש, מה שאומר לי שהמודל לא שבור, הוא פשוט מכוון לרגישות הלא נכונה — הוא חסר-ביטחון. אם אני מכווננת מחדש את הסף האחד הזה, קו ההחלטה, ה-F1 מתאושש ל-0.75. מה שבאמת נשאר זה פער אוצר-מילים: החלק של המילים שהמודל לא ראה מעולם — 'out-of-vocabulary' — קופץ מ-7% ל-20%. אז ה-0.37 המפחיד מגזים בנזק, אבל פער אמיתי נשאר — וזה בדיוק הטיעון לאימון מחדש על דואר טרי ולמיזוג עם גלעד.</a:t>
             </a:r>
             <a:endParaRPr lang="en-US" dirty="0"/>
           </a:p>
@@ -5742,7 +5768,9 @@
           <a:p>
             <a:r>
               <a:rPr lang="en-US" dirty="0"/>
-              <a:t>Second honesty check: time. On real 2023–2025 phishing, the 2008-trained model catches only 14% — genuine concept drift, the model has aged. And this isn't hypothetical: the obfuscation tricks I defend against are real and growing — mixed-script and zero-width characters are near zero in 2008 phishing but 1.8% and 4% in modern phishing. So the whole robustness study is empirically motivated, not a straw man. The lesson: a lab number has a shelf life; a frozen detector goes blind. The next slide fixes exactly this.</a:t>
+              <a:t>The second reality check is about time. My model was trained on emails from 2008. Here I test it on real phishing from 2023 to 2025 — and it catches only 14% of it. That drop over time has a name: concept drift. It just means the thing you're trying to detect changes over the years — scammers use new words, new brands, new tricks — so a model frozen in the past slowly goes blind. And here's a nice supporting fact: the obfuscation tricks I spent this whole talk defending against are basically absent in 2008 phishing — near 0% — but show up in 1.8% and 4% of modern phishing. Those are things like mixed alphabets and zero-width characters, which are invisible characters hidden inside the text. So my robustness study isn't a made-up threat, it's an emerging real one. The lesson: a lab number has a shelf life, and a frozen detector goes blind. The very next slide shows the fix.
+— — —  עברית  — — —
+בדיקת המציאות השנייה היא על זמן. המודל שלי אומן על מיילים מ-2008. כאן אני בודקת אותו על פישינג אמיתי מ-2023 עד 2025 — והוא תופס רק 14% ממנו. לירידה הזאת לאורך זמן יש שם: הסחת מושג (concept drift). זה פשוט אומר שהדבר שאתה מנסה לזהות משתנה עם השנים — נוכלים משתמשים במילים חדשות, מותגים חדשים, טריקים חדשים — אז מודל שקפוא בעבר לאט לאט מתעוור. והנה עובדה תומכת יפה: טריקי הערפול שהקדשתי להם את כל ההרצאה הזאת כמעט לא קיימים בפישינג של 2008 — קרוב ל-0% — אבל מופיעים ב-1.8% וב-4% מהפישינג המודרני. אלה דברים כמו אלפביתים מעורבים ותווים ברוחב-אפס, שהם תווים בלתי-נראים שמוסתרים בתוך הטקסט. אז מחקר החוסן שלי הוא לא איום מומצא, הוא איום אמיתי ומתפתח. השיעור: לציון מעבדה יש תוקף מוגבל, וגלאי קפוא מתעוור. השקף הבא ממש מראה את התיקון.</a:t>
             </a:r>
             <a:endParaRPr lang="en-US" dirty="0"/>
           </a:p>
@@ -5830,7 +5858,9 @@
           <a:p>
             <a:r>
               <a:rPr lang="en-US" dirty="0"/>
-              <a:t>The ageing is fixable. When I add modern scam examples and retrain, recall on modern scams jumps from 15% to 98% — and, importantly, it doesn't forget: still perfect on old scams, and false alarms stay low at under 1%. I do this carefully — I keep the normal-mail source unchanged so the model can't cheat by learning 'old source versus new source' instead of the scam. The message: a detector that's kept current keeps working; a frozen one goes blind.</a:t>
+              <a:t>The good news is that the ageing problem is fixable, and simply. When I add some modern scam examples and retrain the model, its recall on modern scams jumps from 15% to 98%. And two things I checked carefully. First, it doesn't forget — a real risk in machine learning called catastrophic forgetting, where learning new things wipes out the old. Here it stays perfect on the old scams too. Second, false alarms don't go up — they stay under 1%, so it doesn't start bothering people about legitimate mail. I also did it honestly: I kept the normal-mail source unchanged during retraining, so the model can't cheat by learning 'old source versus new source' instead of actually learning the new scams. The message is simple: a detector that's kept current keeps working; a frozen one goes blind.
+— — —  עברית  — — —
+החדשות הטובות הן שבעיית ההתיישנות ניתנת לתיקון, ובפשטות. כשאני מוסיפה כמה דוגמאות של הונאות מודרניות ומאמנת מחדש את המודל, ה-recall שלו על הונאות מודרניות קופץ מ-15% ל-98%. ושני דברים שבדקתי בקפידה. ראשית, הוא לא שוכח — סיכון אמיתי בלמידת מכונה שנקרא שכחה קטסטרופלית (catastrophic forgetting), שבה למידת דברים חדשים מוחקת את הישנים. כאן הוא נשאר מושלם גם על ההונאות הישנות. שנית, אזעקות השווא לא עולות — הן נשארות מתחת ל-1%, אז הוא לא מתחיל להטריד אנשים על דואר לגיטימי. גם עשיתי את זה בכנות: שמרתי את מקור הדואר-הרגיל ללא שינוי במהלך האימון מחדש, כדי שהמודל לא יוכל לרמות על ידי לימוד 'מקור ישן מול מקור חדש' במקום באמת ללמוד את ההונאות החדשות. המסר פשוט: גלאי שנשמר עדכני ממשיך לעבוד; קפוא מתעוור.</a:t>
             </a:r>
             <a:endParaRPr lang="en-US" dirty="0"/>
           </a:p>
@@ -5918,7 +5948,9 @@
           <a:p>
             <a:r>
               <a:rPr lang="en-US" dirty="0"/>
-              <a:t>A detector in an organisation sits next to people. If one employee reports a scam, can we catch the rest of that wave? Yes: the system compares the report to every inbox and blocks the near-duplicates — recall on the rest goes from 15% to 100%, with no extra false alarms. I'm honest about it: the genuine campaign effect is the 1.0 versus 0.33 gap; the rest is just 'having a recent example helps.' And the gold box is the point you asked me to stress: attackers increasingly hijack a REAL trusted account and send phishing from a legitimate address. A filter that trusts the sender is fooled — but reading the actual words still spots that something is wrong. Content is the signal that survives a stolen account. One caveat: this only works once look-alike letters are normalised first — so that certified defence is a precondition, not optional.</a:t>
+              <a:t>Here's a practical idea, because a detector in a real company sits next to people. Imagine one employee spots a scam and reports it. Can we use that one report to protect everyone else? A phishing campaign is usually the same email blasted to hundreds of inboxes with tiny changes. So the system takes the reported email and compares it to every other inbox, looking for near-duplicates — emails that are almost the same. When it finds them, it blocks them. The result: recall on the rest of that campaign goes from 15% to 100%, with no extra false alarms. I stay honest about the numbers — the genuine effect of matching the campaign is the 1.0 versus 0.33 gap; some of the lift is just 'having a fresh example helps'. And the gold box is a point worth stressing: attackers now often hijack a REAL, trusted account and send the phishing from a legitimate address. A filter that trusts the sender gets completely fooled by that — but a filter that reads the actual words still notices something is wrong. Content is the signal that survives a stolen account. One caveat: this whole thing only works if I normalise the look-alike letters first, so that certified defence from earlier is a requirement here, not optional.
+— — —  עברית  — — —
+הנה רעיון פרקטי, כי גלאי בחברה אמיתית יושב ליד אנשים. תארו לעצמכם שעובד אחד מזהה הונאה ומדווח עליה. האם נוכל להשתמש בדיווח האחד הזה כדי להגן על כל השאר? קמפיין פישינג הוא בדרך כלל אותו מייל שנשלח למאות תיבות עם שינויים זעירים. אז המערכת לוקחת את המייל שדווח ומשווה אותו לכל תיבה אחרת, מחפשת כפילויות-קרובות — מיילים כמעט זהים. כשהיא מוצאת אותם, היא חוסמת אותם. התוצאה: ה-recall על שאר הקמפיין עולה מ-15% ל-100%, בלי אזעקות שווא נוספות. אני נשארת כנה לגבי המספרים — האפקט האמיתי של התאמת הקמפיין הוא הפער 1.0 מול 0.33; חלק מהעלייה זה פשוט 'דוגמה טרייה עוזרת'. והקופסה הזהובה היא נקודה ששווה להדגיש: תוקפים היום לעיתים קרובות חוטפים חשבון אמיתי ומהימן ושולחים את הפישינג מכתובת לגיטימית. מסנן שסומך על השולח מרומה לגמרי מזה — אבל מסנן שקורא את המילים עצמן עדיין שם לב שמשהו לא בסדר. תוכן הוא האות ששורד חשבון גנוב. הסתייגות אחת: כל הדבר הזה עובד רק אם אני מנרמלת קודם את האותיות הדומות, אז ההגנה המאושרת מקודם היא דרישה כאן, לא רשות.</a:t>
             </a:r>
             <a:endParaRPr lang="en-US" dirty="0"/>
           </a:p>
@@ -6006,7 +6038,9 @@
           <a:p>
             <a:r>
               <a:rPr lang="en-US" dirty="0"/>
-              <a:t>An additional idea, and the one honest open frontier. The attack: an LLM rewrites the scam in new words. The risk with any rewrite is that it stops being a scam — so a second, independent LLM judges whether each rewrite is still phishing before I count it. That's 'LLM-as-a-judge'; it kept 24 of 30. The result: my main model shrugs it off, recall stays 1.0, because its redundant word-and-character features absorb the rewrite. The monotone safety-net model gives a little ground, 0.75 to 0.71 — the honest counterweight to its certificate, since it deliberately has no negative evidence. Caveats: small N, attacker and judge share a model family, and outputs are frozen for reproducibility.</a:t>
+              <a:t>This is an extra idea I explored, and it probes the one attack that's still open. The attack: instead of tricking letters or padding words, I ask an LLM — a large language model like ChatGPT — to rewrite the whole scam in fresh words while keeping the same meaning. That's a paraphrase attack. But there's a catch: a rewrite might accidentally stop being a scam, and then it wouldn't be fair to call it an evasion. So I use a second, independent LLM as a judge to check that each rewrite is still genuinely phishing before I count it. That technique is called 'LLM-as-a-judge', and it kept 24 of the 30 rewrites. The result: my main model shrugs it off — recall stays 1.0 — because it has lots of overlapping word and character clues, so changing the wording doesn't remove all of them. My one-way safety-net model gives a little ground, 0.75 to 0.71, which is the honest downside of its guarantee, since it deliberately ignores 'innocent' evidence. I'm upfront about the caveats: the sample is small, the attacker and the judge are from the same AI family, and I froze the outputs so the experiment reproduces.
+— — —  עברית  — — —
+זה רעיון נוסף שחקרתי, והוא בוחן את המתקפה האחת שעדיין פתוחה. המתקפה: במקום לרמות אותיות או למלא מילים, אני מבקשת ממודל שפה גדול — LLM כמו ChatGPT — לכתוב מחדש את כל ההונאה במילים חדשות תוך שמירה על אותה משמעות. זו מתקפת פרפרזה (paraphrase). אבל יש מלכוד: כתיבה מחדש עלולה בטעות להפסיק להיות הונאה, ואז לא הוגן לקרוא לזה התחמקות. אז אני משתמשת ב-LLM שני ועצמאי כשופט כדי לבדוק שכל כתיבה מחדש עדיין באמת פישינג לפני שאני סופרת אותה. הטכניקה הזאת נקראת 'LLM-as-a-judge', והיא שמרה 24 מתוך 30 הכתיבות מחדש. התוצאה: המודל הראשי שלי לא מתרגש — ה-recall נשאר 1.0 — כי יש לו הרבה רמזי מילים ותווים חופפים, אז שינוי הניסוח לא מסיר את כולם. מודל רשת-הביטחון החד-כיווני שלי מוותר קצת, 0.75 ל-0.71, וזה החיסרון הכן של ההבטחה שלו, כי הוא בכוונה מתעלם מראיות 'תמימות'. אני שקופה לגבי ההסתייגויות: המדגם קטן, התוקף והשופט הם מאותה משפחת AI, והקפאתי את הפלטים כדי שהניסוי ישתחזר.</a:t>
             </a:r>
             <a:endParaRPr lang="en-US" dirty="0"/>
           </a:p>
@@ -6094,7 +6128,9 @@
           <a:p>
             <a:r>
               <a:rPr lang="en-US" dirty="0"/>
-              <a:t>Another idea that ties the whole talk together: instead of a frozen model, a standing process. A new attack arrives — from a user report, a drift monitor, or a honeypot; it's validated as really being an attack; stored in a living database; folded into a retrain that costs about 30 seconds; and the detector is ready for the next one. It's grounded, not hand-wavy: the evolve step already proved retraining lifts recall 0.15 to 0.98, and retraining is cheap. The hard part is trust — an untrusted stream can be poisoned, so every new entry is judged before it's learned, exactly the poisoning caveat from the human-in-the-loop result.</a:t>
+              <a:t>One more idea, and it ties the whole talk together: instead of a model frozen in time, imagine a living, self-updating process. A new attack shows up — maybe from a user report, maybe from a monitor that notices drift, maybe from a honeypot, which is a fake inbox set up as bait to collect fresh scams. The system validates that it really is an attack, stores it in a growing database, and folds it into a retrain — which, remember, takes only about 30 seconds — and then it's ready for the next one. I like this because it's grounded in results I already showed, not hand-waving: the evolve slide proved retraining lifts recall from 0.15 to 0.98, and retraining is cheap. The hard part is trust. If you learn from an untrusted stream, an attacker can feed you bad data on purpose to corrupt the model — that's called a poisoning attack. So every new entry has to be validated, by the LLM judge or a human, before the model is allowed to learn from it.
+— — —  עברית  — — —
+עוד רעיון אחד, והוא קושר את כל ההרצאה יחד: במקום מודל קפוא בזמן, דמיינו תהליך חי שמעדכן את עצמו. מתקפה חדשה מופיעה — אולי מדיווח משתמש, אולי ממוניטור שמבחין בדריפט, אולי מ-honeypot, שזו תיבת דואר מזויפת שמוקמת כפיתיון כדי לאסוף הונאות טריות. המערכת מאמתת שזו באמת מתקפה, שומרת אותה במסד נתונים גדל, ומשלבת אותה באימון מחדש — שכזכור לוקח רק בערך 30 שניות — ואז היא מוכנה לבאה. אני אוהבת את זה כי זה מבוסס על תוצאות שכבר הראיתי, לא דיבורים בעלמא: שקף האבולוציה הוכיח שאימון מחדש מרים את ה-recall מ-0.15 ל-0.98, ואימון מחדש זול. החלק הקשה הוא אמון. אם לומדים מזרם לא מהימן, תוקף יכול להזין לך דאטה רע בכוונה כדי לקלקל את המודל — זה נקרא מתקפת הרעלה (poisoning). אז כל רשומה חדשה חייבת לעבור אימות, על ידי שופט ה-LLM או אדם, לפני שמותר למודל ללמוד ממנה.</a:t>
             </a:r>
             <a:endParaRPr lang="en-US" dirty="0"/>
           </a:p>
@@ -6182,7 +6218,9 @@
           <a:p>
             <a:r>
               <a:rPr lang="en-US" dirty="0"/>
-              <a:t>Practical numbers, measured not guessed. It classifies an email in about 3 milliseconds, the whole model is under 3 megabytes, it handles hundreds per second per core, and a full retrain takes about 25 seconds. Because it's so small it can run on the phone or mail client itself, so the email content never has to leave the device — good for privacy. And I always frame it as one layer of many: it deliberately ignores the sender and links, so a real deployment surrounds it with other checks and the partner detector. Honest scope: parsing MIME, HTML and attachments is not yet handled.</a:t>
+              <a:t>A quick word on the practical side — could this actually run somewhere, and these numbers I measured, I didn't guess. It classifies one email in about 3 milliseconds, so basically instant. The whole model is under 3 megabytes, smaller than a photo. It handles hundreds of emails per second on a single processor core, and a full retrain takes about 25 seconds. Because it's so small and fast, it can run on the phone or mail app itself — which means the email content never has to be sent to a server, and that's good for privacy. And I always frame it honestly as one layer of many: it deliberately ignores the sender and the links, so in a real deployment it would sit inside a stack with things like sender authentication, link reputation, sandboxing, and of course Gilad's detector. Honest about scope: I work on already-extracted text — parsing real email formats, HTML and attachments, isn't handled yet.
+— — —  עברית  — — —
+מילה מהירה על הצד המעשי — האם זה באמת יכול לרוץ איפשהו, והמספרים האלה שמדדתי, לא ניחשתי. הוא מסווג מייל אחד בערך ב-3 מילישניות, כלומר בעצם מיידי. כל המודל הוא מתחת ל-3 מגה-בייט, קטן יותר מתמונה. הוא מטפל במאות מיילים בשנייה על ליבת מעבד אחת, ואימון מחדש מלא לוקח בערך 25 שניות. כי הוא כל כך קטן ומהיר, הוא יכול לרוץ על הטלפון או אפליקציית המייל עצמה — מה שאומר שתוכן המייל אף פעם לא צריך להישלח לשרת, וזה טוב לפרטיות. ואני תמיד ממסגרת אותו בכנות כשכבה אחת מיני רבות: הוא בכוונה מתעלם מהשולח ומהקישורים, אז בפריסה אמיתית הוא היה יושב בתוך מערך עם דברים כמו אימות שולח, מוניטין קישורים, ארגז חול, וכמובן הגלאי של גלעד. כנה לגבי ההיקף: אני עובדת על טקסט שכבר חולץ — פירוק פורמטים אמיתיים של מייל, HTML וקבצים מצורפים, עדיין לא מטופל.</a:t>
             </a:r>
             <a:endParaRPr lang="en-US" dirty="0"/>
           </a:p>
@@ -6270,7 +6308,9 @@
           <a:p>
             <a:r>
               <a:rPr lang="en-US" dirty="0"/>
-              <a:t>If you remember one slide, this one. Three things. One: it works, and honestly — near-perfect on clean data, but every claim is tested against an attacker, not just easy examples. Two: two whole classes of attack are shut with a proof, not just a better score. Three: it knows its limits — reading words alone can't catch everything, which is the whole reason it's fused with the link-and-sender detector. The one-line core: a near-perfect score is not the same as a safe detector. The value of this project is knowing where it fails, and proving where it can't.</a:t>
+              <a:t>If you remember only one slide, make it this one — it's the core of the whole project in three points. One: it works, and honestly. Near-perfect on clean data, but I tested every claim against an attacker who fights back, not just on easy examples. Two: two entire classes of attack — letter tricks and word-padding — are shut with a mathematical proof, not just a better score. Three: it knows its own limits. Reading words alone can't catch everything, and instead of hiding that, I lean into it — it's exactly why the content detector is fused with Gilad's link-and-sender detector. The one line I want to leave you with: a near-perfect score is not the same as a safe detector. The real value of this project is knowing precisely where it fails, and proving where it cannot.
+— — —  עברית  — — —
+אם תזכרו רק שקף אחד, שיהיה זה — זה הליבה של כל הפרויקט בשלוש נקודות. אחת: הוא עובד, ובכנות. כמעט מושלם על דאטה נקי, אבל בדקתי כל טענה מול תוקף שנלחם בחזרה, לא רק על דוגמאות קלות. שתיים: שתי מחלקות שלמות של מתקפות — טריקי-אותיות ומילוי-מילים — סגורות בהוכחה מתמטית, לא רק בציון טוב יותר. שלוש: הוא מכיר את המגבלות של עצמו. קריאת מילים לבד לא יכולה לתפוס הכל, ובמקום להסתיר את זה, אני נשענת על זה — זו בדיוק הסיבה שגלאי התוכן ממוזג עם גלאי הקישורים-והשולח של גלעד. השורה האחת שאני רוצה להשאיר אתכם איתה: ציון כמעט מושלם הוא לא אותו דבר כמו גלאי בטוח. הערך האמיתי של הפרויקט הוא לדעת בדיוק איפה הוא נכשל, ולהוכיח איפה הוא לא יכול.</a:t>
             </a:r>
             <a:endParaRPr lang="en-US" dirty="0"/>
           </a:p>
@@ -6358,7 +6398,9 @@
           <a:p>
             <a:r>
               <a:rPr lang="en-US" dirty="0"/>
-              <a:t>I want to show this isn't ad-hoc — it maps straight onto the course's general project pipeline: data and EDA, clustering, temporal analysis, NLP, models, and improvement. My project is a deep dive into the NLP, models, and improvement stages — the gold boxes — while touching every earlier box: I do the statistics and correlation, I look at campaigns as clusters, I study drift over fifteen years. The single box I deliberately leave open is combining separate components — and that is exactly the fusion with Gilad, submitted jointly.</a:t>
+              <a:t>I want to show my project isn't random — it follows the exact general pipeline we were taught in the course: start with data and EDA, then clustering, then temporal analysis, then NLP, then models, then improvement. My project is a deep dive into the last three — NLP, models, and improvement, the gold boxes — but I still touch every earlier stage along the way: I did the statistics and correlation for EDA, I looked at phishing campaigns as clusters, and I studied drift over fifteen years, which is the temporal part. The one box I deliberately leave open is 'combining separate components' — and that's exactly the fusion with Gilad, which we submit together. So the talk maps one-to-one onto the course pipeline.
+— — —  עברית  — — —
+אני רוצה להראות שהפרויקט שלי לא אקראי — הוא עוקב בדיוק אחרי ה-pipeline הכללי שלמדנו בקורס: מתחילים בדאטה ו-EDA, אחר כך clustering (אשכולות), אחר כך ניתוח טמפורלי, אחר כך NLP, אחר כך מודלים, אחר כך שיפור. הפרויקט שלי הוא צלילה עמוקה לשלושת האחרונים — NLP, מודלים, ושיפור, הקופסאות הזהובות — אבל אני עדיין נוגעת בכל שלב מוקדם יותר בדרך: עשיתי את הסטטיסטיקה והקורלציה ל-EDA, הסתכלתי על קמפיינים של פישינג כאשכולות, וחקרתי דריפט לאורך חמש-עשרה שנים, שזה החלק הטמפורלי. הקופסה האחת שאני משאירה בכוונה פתוחה היא 'שילוב רכיבים נפרדים' — וזה בדיוק המיזוג עם גלעד, שאותו אנחנו מגישים ביחד. אז ההרצאה ממופה אחד-לאחד על ה-pipeline של הקורס.</a:t>
             </a:r>
             <a:endParaRPr lang="en-US" dirty="0"/>
           </a:p>
@@ -6446,7 +6488,9 @@
           <a:p>
             <a:r>
               <a:rPr lang="en-US" dirty="0"/>
-              <a:t>This is the syllabus, executed. Top-left: the metrics lecture warned that high accuracy can mean zero phishing caught — so I report F2, MCC and AUC, and I keep the majority baseline in the deck as a live example. Top-right: the leakage discipline — a stratified 60/20/20 split with a fixed seed, dedupe before splitting, the vectoriser fit on training data only, and the 'no email from the future' rule. Bottom-left: the EDA and statistics — rank correlations, skew and kurtosis, robust spread measures, a Mann–Whitney test, and a VIF redundancy check. Bottom-right: the three levels of explainability — model, feature, and instance — all delivered, with the trust-versus-performance trade-off as my fourth research question.</a:t>
+              <a:t>This slide shows the course material actually used, not just mentioned. Top-left, metrics: the lecture warned that high accuracy can hide zero phishing caught, so I report better scores — F2, MCC, AUC — and I keep that useless majority baseline in the deck as a live example of the trap. Top-right, avoiding leakage: leakage means the model accidentally sees test answers during training and looks better than it really is. I prevent it with a stratified split — stratified just means each split keeps the same phishing-to-legit ratio — a fixed seed, removing duplicates before splitting, fitting the text processor on training data only, and the 'no email from the future' rule. Bottom-left, the statistics: rank correlations, skew and kurtosis which measure the shape of the data, robust averages, the Mann–Whitney test, and the VIF check. Bottom-right, explainability at three levels — the whole model, each feature, and a single email's decision — all delivered, and the trust-versus-performance trade-off is my fourth research question.
+— — —  עברית  — — —
+השקף הזה מראה את חומר הקורס שבאמת השתמשתי בו, לא רק הזכרתי. שמאל-למעלה, מדדים: ההרצאה הזהירה שדיוק גבוה יכול להסתיר אפס פישינג שנתפס, אז אני מדווחת ציונים טובים יותר — F2, MCC, AUC — ואני שומרת את בסיס-הרוב חסר-התועלת בדק כדוגמה חיה של המלכודת. ימין-למעלה, מניעת דליפה: דליפה (leakage) אומרת שהמודל בטעות רואה את תשובות המבחן במהלך האימון ונראה טוב יותר ממה שהוא באמת. אני מונעת אותה עם פיצול שכבתי — stratified פשוט אומר שכל פיצול שומר על אותו יחס פישינג-ללגיטימי — seed קבוע, הסרת כפילויות לפני הפיצול, התאמת מעבד הטקסט על נתוני האימון בלבד, וכלל 'אין מייל מהעתיד'. שמאל-למטה, הסטטיסטיקה: קורלציות דירוג, skew ו-kurtosis שמודדים את צורת הדאטה, ממוצעים חסינים, מבחן מאן-וויטני, ובדיקת VIF. ימין-למטה, הסברתיות בשלוש רמות — כל המודל, כל תכונה, וההחלטה של מייל בודד — הכל מסופק, והטרייד-אוף בין אמון לביצועים הוא שאלת המחקר הרביעית שלי.</a:t>
             </a:r>
             <a:endParaRPr lang="en-US" dirty="0"/>
           </a:p>
@@ -6534,7 +6578,9 @@
           <a:p>
             <a:r>
               <a:rPr lang="en-US" dirty="0"/>
-              <a:t>The full system has two detectors. Mine reads only the email's words. Gilad's reads the links and the sender address. They're combined at the end. The idea: two independent signals, so if an attacker beats one, the other still fires. I strip URLs out of my text on purpose — otherwise my model could cheat using the link, which is Gilad's job. So everything you see is content-only. Fusion is submitted jointly; the rest of this talk is my half.</a:t>
+              <a:t>Quick picture of how my part fits in. The full system has two separate detectors. Mine, on the left, reads only the words — the subject and the body. Gilad's reads the links and the sender's address. At the end we combine the two — that's the 'fusion' in PhishFusion. The reason we built it as two independent parts is simple: if an attacker manages to fool one of them, the other one still fires. One choice I want to point out: I deliberately remove the URLs, the web links, from my text before the model sees it. Otherwise my model could 'cheat' by just looking at the suspicious link — but the link is Gilad's job, not mine. So everything I show you today is content-only, words only. The fusion itself we submit together; today is just my half.
+— — —  עברית  — — —
+תמונה מהירה של איך החלק שלי משתלב. המערכת המלאה מורכבת משני גלאים נפרדים. שלי, משמאל, קורא רק את המילים — הנושא והגוף. של גלעד קורא את הקישורים ואת כתובת השולח. בסוף אנחנו משלבים בין השניים — זה ה-'fusion' שבשם PhishFusion. הסיבה שבנינו את זה כשני חלקים עצמאיים פשוטה: אם תוקף מצליח לרמות אחד מהם, השני עדיין מתריע. בחירה אחת שאני רוצה להדגיש: אני מסירה בכוונה את ה-URL, הקישורים, מהטקסט לפני שהמודל רואה אותו. אחרת המודל שלי היה יכול 'לרמות' פשוט על ידי הסתכלות על הקישור החשוד — אבל הקישור זה התפקיד של גלעד, לא שלי. אז כל מה שאני מראה היום זה תוכן בלבד, מילים בלבד. את השילוב עצמו אנחנו מגישים ביחד; היום זה רק החצי שלי.</a:t>
             </a:r>
             <a:endParaRPr lang="en-US" dirty="0"/>
           </a:p>
@@ -6622,7 +6668,9 @@
           <a:p>
             <a:r>
               <a:rPr lang="en-US" dirty="0"/>
-              <a:t>The attacks and defences also come straight from the course taxonomy. Top-left: the adversarial-ML taxonomy — my homoglyphs are evasion, the importance-guided attack is targeted grey-box, false reports are poisoning, and DistilBERT is the transfer test. Top-right: the NLP-security lecture's own examples — 'Get r1ch qu1ck', Cyrillic 'paypal', and sub-word tokenizers breaking on perturbed tokens — are literally my attacks. Bottom-left: the lectures name normalisation and adversarial training as the defences, which is exactly my UTS-39 certificate plus adversarial training. Bottom-right: anomaly detection — Isolation Forest, One-Class SVM, Mahalanobis — is my named next step. And the framing for drift is the course's too: a 2008 model is Taleb's turkey, confident right up to Thanksgiving.</a:t>
+              <a:t>The attacks and defences also map onto the course's taxonomy — the way we were taught to classify them. Top-left: attacks come in types. Evasion means fooling the model at test time; poisoning means corrupting its training data; and transfer means an attack built for one model that also works on another. My homoglyphs are evasion, my targeted attack is a smarter evasion, fake reports are poisoning, and testing on DistilBERT is the transfer test. Top-right: the NLP-security lecture literally used examples like 'Get r1ch qu1ck' and Cyrillic 'paypal' — which are exactly my attacks. Bottom-left: the same lectures name normalisation and adversarial training as the standard defences, and those are precisely what I built. Bottom-right: anomaly detection methods — Isolation Forest and One-Class SVM, which learn what 'normal' looks like and flag anything weird — are my named next step. And even my framing for drift is from the course: a 2008 model is like Taleb's turkey — fed every day, completely confident, right up until Thanksgiving. Trusting the past to predict the future is the exact trap.
+— — —  עברית  — — —
+גם המתקפות וההגנות ממופות על הטקסונומיה של הקורס — הדרך שבה לימדו אותנו לסווג אותן. שמאל-למעלה: מתקפות מגיעות בסוגים. התחמקות (evasion) אומרת לרמות את המודל בזמן הבדיקה; הרעלה (poisoning) אומרת לקלקל את נתוני האימון שלו; והעברה (transfer) אומרת מתקפה שנבנתה למודל אחד ועובדת גם על אחר. ההומוגליפים שלי הם evasion, המתקפה הממוקדת שלי היא evasion חכמה יותר, דיווחים מזויפים הם poisoning, ובדיקה על DistilBERT היא מבחן ה-transfer. ימין-למעלה: הרצאת אבטחת ה-NLP ממש השתמשה בדוגמאות כמו 'Get r1ch qu1ck' ו-'paypal' קירילי — שהן בדיוק המתקפות שלי. שמאל-למטה: אותן הרצאות מנקבות בשם נורמליזציה ואימון יריב כהגנות הסטנדרטיות, ואלה בדיוק מה שבניתי. ימין-למטה: שיטות זיהוי חריגות — Isolation Forest ו-One-Class SVM, שלומדות איך 'נורמלי' נראה ומסמנות כל דבר מוזר — הן הצעד הבא שנקבתי בשמו. ואפילו המסגור שלי לדריפט הוא מהקורס: מודל 2008 הוא כמו התרנגול-הודו של טאלב — מאכילים אותו כל יום, בטוח לגמרי, עד יום ההודיה. לסמוך על העבר כדי לחזות את העתיד היא בדיוק המלכודת.</a:t>
             </a:r>
             <a:endParaRPr lang="en-US" dirty="0"/>
           </a:p>
@@ -6710,7 +6758,9 @@
           <a:p>
             <a:r>
               <a:rPr lang="en-US" dirty="0"/>
-              <a:t>Future work, and I've grounded each direction in a specific paper from the report — stated as a possibility, not a claim. One: dilution still costs me nine points of clean F1; Fleshman 2018's non-negative networks and the multiple-instance view of the good-word attack suggest it may be possible to keep the guarantee without that cost. Two: my paraphrase probe was small and rule-based; Li 2019's TextBugger and DeepWordBug show a learned neural attacker could push the semantic frontier much harder. Three: Pruthi 2019 puts a robust word-recognition stage in front of the model, which could extend my certificate from look-alikes to ordinary typos. Four: the abnormality lecture's Isolation Forest and One-Class SVM, plus my finding that obfuscation is rare in normal mail, point to an adversarial-input detector — and above all, the fusion with Gilad. A GPU full-data DistilBERT run is the last loose end.</a:t>
+              <a:t>For future work I didn't want to just list wishes, so each direction is grounded in a specific paper from my report, and I phrase them as possibilities, not promises — 'according to this paper, it may be possible to...'. One: my dilution defence costs me nine points of clean F1; Fleshman's 2018 paper on non-negative networks, and the multiple-instance view of the good-word attack, suggest it may be possible to keep the guarantee without paying that price. Two: my paraphrase attack was small and rule-based; Li's 2019 TextBugger and DeepWordBug show that a proper learned, neural attacker could push that frontier much harder — so I'd want to test against a stronger opponent. Three: Pruthi's 2019 paper puts a robust word-recognition stage in front of the model, which could extend my certificate from look-alike letters to ordinary typos and misspellings. Four: the anomaly-detection methods from class — Isolation Forest, One-Class SVM — plus my own finding that obfuscation is rare in normal mail, point to a separate detector that flags weird, obfuscated emails as anomalies. And above all of these, the big one: actually fusing with Gilad's detector. The last loose end is running DistilBERT on a GPU with the full dataset to find its true ceiling.
+— — —  עברית  — — —
+לעבודה עתידית לא רציתי סתם לרשום משאלות, אז כל כיוון מבוסס על מאמר ספציפי מהדוח שלי, ואני מנסחת אותם כאפשרויות, לא הבטחות — 'לפי המאמר הזה, ייתכן שאפשר...'. אחת: הגנת הדילול שלי עולה לי תשע נקודות של F1 נקי; המאמר של פלשמן מ-2018 על רשתות אי-שליליות, והמבט של למידה מרובת-מופעים על מתקפת המילים-הטובות, מרמזים שייתכן שאפשר לשמור על ההבטחה בלי לשלם את המחיר הזה. שתיים: מתקפת הפרפרזה שלי הייתה קטנה ומבוססת-כללים; TextBugger ו-DeepWordBug של לי מ-2019 מראים שתוקף נוירוני נלמד אמיתי יכול לדחוף את החזית הזאת הרבה יותר חזק — אז הייתי רוצה לבדוק מול יריב חזק יותר. שלוש: המאמר של פרות'י מ-2019 שם שלב זיהוי-מילים חסין לפני המודל, שיכול להרחיב את התעודה שלי מאותיות-דומות לשגיאות כתיב רגילות. ארבע: שיטות זיהוי-החריגות מהשיעור — Isolation Forest, One-Class SVM — יחד עם הממצא שלי שערפול נדיר בדואר רגיל, מצביעות על גלאי נפרד שמסמן מיילים מוזרים ומעורפלים כחריגים. ומעל כל אלה, הגדול: באמת למזג עם הגלאי של גלעד. הקצה הפתוח האחרון הוא להריץ את DistilBERT על GPU עם כל הדאטהסט כדי למצוא את התקרה האמיתית שלו.</a:t>
             </a:r>
             <a:endParaRPr lang="en-US" dirty="0"/>
           </a:p>
@@ -6798,7 +6848,9 @@
           <a:p>
             <a:r>
               <a:rPr lang="en-US" dirty="0"/>
-              <a:t>To close: the contribution isn't the 0.998. It's showing exactly where a near-perfect detector breaks, and hardening it until two whole classes of attack are provably shut. It's honest about what content-only can't do — which is precisely why it fuses with the second detector. Happy to take questions.</a:t>
+              <a:t>To close, the one sentence I want to leave you with: the real contribution of this project isn't the 0.998 score. It's showing exactly where a near-perfect detector breaks, and then hardening it until two whole classes of attack are provably, mathematically shut. And it's honest about what a content-only model simply cannot do on its own — which is the whole reason it's built to fuse with Gilad's second detector. Thank you so much for listening, and I'm happy to take any questions.
+— — —  עברית  — — —
+לסיום, המשפט האחד שאני רוצה להשאיר אתכם איתו: התרומה האמיתית של הפרויקט הזה היא לא הציון 0.998. היא להראות בדיוק איפה גלאי כמעט-מושלם נשבר, ואז לחזק אותו עד ששתי מחלקות שלמות של מתקפות סגורות בהוכחה, מתמטית. והוא כן לגבי מה שמודל מבוסס-תוכן בלבד פשוט לא יכול לעשות לבד — וזו כל הסיבה שהוא בנוי להתמזג עם הגלאי השני של גלעד. תודה רבה שהקשבתם, ואשמח לענות על כל שאלה.</a:t>
             </a:r>
             <a:endParaRPr lang="en-US" dirty="0"/>
           </a:p>
@@ -6886,7 +6938,9 @@
           <a:p>
             <a:r>
               <a:rPr lang="en-US" dirty="0"/>
-              <a:t>This is how I worked, and it's the actual contribution. Step one, build a strong, explainable model on a clean pipeline. Step two, study attacks from academic papers and known adversarial techniques. Step three, adapt — design attacks aimed specifically at my model's weak points. Step four, defend — fix each weakness, then attack the fix, and loop. The important framing: every broken version you're about to see is not a failure. Finding and fixing those holes IS the method. A near-perfect score means nothing until someone has tried to break it.</a:t>
+              <a:t>This slide is how I actually worked — and honestly it's the real contribution, more than any single number. Four steps in a loop. One, build: a strong model with a clean, careful pipeline. Two, study: I read academic papers to learn the known ways people attack text models — I didn't invent the attacks from scratch. Three, adapt: I take those ideas and aim them specifically at the weak spots of my own model — an attacker who studies the target is called an adaptive or adversarial attacker; 'adversarial' just means an opponent who actively fights back instead of random noise. Four, defend: I fix each weakness, and then I attack the fix again. And I loop. The important message: every broken version you're about to see is not a failure or a mistake. Finding the holes and closing them IS the method. A near-perfect score means nothing until someone has genuinely tried to break it.
+— — —  עברית  — — —
+השקף הזה הוא איך שבאמת עבדתי — ובכנות זו התרומה האמיתית, יותר מכל מספר בודד. ארבעה שלבים בלולאה. אחת, לבנות: מודל חזק עם pipeline נקי ומסודר. שתיים, ללמוד: קראתי מאמרים אקדמיים כדי להכיר את הדרכים הידועות שבהן תוקפים מודלים של טקסט — לא המצאתי את המתקפות מאפס. שלוש, להתאים: לקחת את הרעיונות האלה ולכוון אותם ספציפית לנקודות החולשה של המודל שלי — תוקף שלומד את המטרה נקרא תוקף אדפטיבי או יריב (adversarial); 'adversarial' פשוט אומר יריב שנלחם בחזרה באופן פעיל, לא רעש אקראי. ארבע, להגן: לתקן כל חולשה, ואז לתקוף שוב את התיקון. וללולאה. המסר החשוב: כל גרסה שבורה שאתם עומדים לראות היא לא כישלון ולא טעות. למצוא את החורים ולסגור אותם — זו השיטה. ציון כמעט מושלם לא שווה כלום עד שמישהו באמת ניסה לשבור אותו.</a:t>
             </a:r>
             <a:endParaRPr lang="en-US" dirty="0"/>
           </a:p>
@@ -6974,7 +7028,9 @@
           <a:p>
             <a:r>
               <a:rPr lang="en-US" dirty="0"/>
-              <a:t>How one email becomes a decision, in five steps. Take subject and body; clean it — strip links and fold look-alike letters; turn it into numbers with TF-IDF over both whole words and character chunks; combine into one feature vector; and classify with Logistic Regression. Three design choices matter: character n-grams give robustness (even 'cl1ck' shares letter-chunks with 'click'); the linear model stays explainable — I can point to the exact words that flagged an email; and URLs are stripped because links are the partner's job. It's simple, fast, and transparent — which the robustness study needs.</a:t>
+              <a:t>This is how one email becomes a decision, in five steps, and I'll explain the two method names on the box. First I take the subject and body and clean the text. Then the key step: TF-IDF. A model can't read words, only numbers, so TF-IDF turns each email into numbers. The idea is simple — for every word it asks two things: how often does this word appear in THIS email (that's the TF, term frequency), and how rare is it across ALL emails (that's the IDF). A word like 'the' appears everywhere, so it gets a low weight; a word like 'suspended' is rarer and more informative, so it gets a high weight. That's the formula at the top. I do this twice — over whole words, and over small chunks of letters called character n-grams, for example 3 to 5 letters at a time. Whole words are readable; character chunks are the robustness trick, because even if someone writes 'cl1ck' with a one, it still shares the chunks 'lic' and 'ick' with the real 'click'. I join both into one big list of numbers — a feature vector — and feed it to Logistic Regression. That just means: multiply each word's weight by how much the model trusts it, add it all up, and squash the total into a probability between 0 and 1 — that's the second formula. I chose it because it's linear and therefore explainable — I can point to the exact words that flagged an email.
+— — —  עברית  — — —
+ככה מייל אחד הופך להחלטה, בחמישה שלבים, ואסביר את שני שמות השיטות שעל הקופסה. קודם אני לוקחת את הנושא והגוף ומנקה את הטקסט. אחר כך השלב המרכזי: TF-IDF. מודל לא יודע לקרוא מילים, רק מספרים, אז TF-IDF הופך כל מייל למספרים. הרעיון פשוט — לכל מילה הוא שואל שני דברים: כמה פעמים המילה הזאת מופיעה במייל הזה (זה ה-TF, תדירות המילה), וכמה היא נדירה בכל המיילים (זה ה-IDF). מילה כמו 'the' מופיעה בכל מקום, אז היא מקבלת משקל נמוך; מילה כמו 'suspended' נדירה יותר ואינפורמטיבית יותר, אז היא מקבלת משקל גבוה. זו הנוסחה למעלה. אני עושה את זה פעמיים — על מילים שלמות, ועל מקטעים קטנים של אותיות שנקראים character n-grams, למשל 3 עד 5 אותיות כל פעם. מילים שלמות ניתנות לקריאה; מקטעי האותיות הם הטריק לחוסן, כי גם אם מישהו כותב 'cl1ck' עם הספרה אחת, זה עדיין חולק את המקטעים 'lic' ו-'ick' עם ה-'click' האמיתי. אני מחברת את שניהם לרשימה אחת גדולה של מספרים — feature vector — ומזינה אותה ל-Logistic Regression (רגרסיה לוגיסטית). זה פשוט אומר: להכפיל את המשקל של כל מילה בכמה שהמודל סומך עליה, לחבר הכל, ולדחוס את הסכום להסתברות בין 0 ל-1 — זו הנוסחה השנייה. בחרתי בה כי היא לינארית ולכן ניתנת להסבר — אני יכולה להצביע על המילים המדויקות שסימנו מייל.</a:t>
             </a:r>
             <a:endParaRPr lang="en-US" dirty="0"/>
           </a:p>
@@ -7062,7 +7118,9 @@
           <a:p>
             <a:r>
               <a:rPr lang="en-US" dirty="0"/>
-              <a:t>The data, and the cleaning — which I want to be explicit about. My main set is CEAS_08, about 27,000 emails with both phishing and normal mail from one source. I also hold out other collections for a fairness test, plus real 2023–2025 phishing and recent normal mail to test ageing, and SpamAssassin to re-check. Cleaning, in order: strip links, tidy spacing, cut over-long mail, drop duplicates before splitting, balance to a realistic 35% phishing, split 60/20/20 with a fixed seed, and hash everything so results reproduce exactly. The key choice, gold box: a probe can guess an email's SOURCE 99% of the time, so I deliberately train on one mixed-class source — otherwise the model cheats by recognising provenance instead of the scam. And two quick checks: normal mail is almost all plain text, which is the clean baseline the letter attack breaks; and the dates are clean, no fake 1970 epoch dates.</a:t>
+              <a:t>Now the data and the cleaning — I want to be very clear about this part, because good data decisions are half the project. My main dataset is CEAS_08: about 27,000 emails that contain both phishing AND normal mail, and importantly all from one source. I also keep other collections aside only for testing fairness, plus real phishing from 2023 to 2025 and recent normal mail to test whether the model ages, and SpamAssassin to double-check. On the right is exactly how I cleaned it, in order: strip the web links, tidy the spacing, cut emails that are way too long, remove duplicates BEFORE I split the data, balance to a realistic 35% phishing — because real inboxes are mostly legitimate — then split into training, validation and test sets 60/20/20 using a fixed seed. A seed is just a fixed starting number so the random split comes out the same every time and anyone can reproduce my results; and I hash the data — a hash is like a fingerprint of the file — so I can prove the numbers came from exactly this data. The gold box is my single most important choice: I ran a quick test and found you can guess which SOURCE an email came from 99% of the time. So if I mixed phishing from one source with normal mail from another, the model would 'cheat' — it would learn to recognise the source instead of the scam. That's why I train on one mixed source. And two quick checks at the bottom: normal mail is almost all plain text, which becomes the clean baseline my letter-attack later breaks; and the dates are clean — no fake '1970' dates, which is what you get when a missing date is filled with a zero.
+— — —  עברית  — — —
+עכשיו הדאטה והניקוי — אני רוצה להיות מאוד ברורה בחלק הזה, כי החלטות טובות על הדאטה הן חצי מהפרויקט. הדאטהסט הראשי שלי הוא CEAS_08: בערך 27,000 מיילים שמכילים גם פישינג וגם דואר רגיל, וחשוב — הכל ממקור אחד. אני גם שומרת בצד אוספים אחרים רק לבדיקת הוגנות, בתוספת פישינג אמיתי מ-2023 עד 2025 ודואר רגיל עדכני כדי לבדוק אם המודל מתיישן, ו-SpamAssassin לבדיקה כפולה. מימין זה בדיוק איך שניקיתי, לפי הסדר: להסיר את הקישורים, לסדר רווחים, לחתוך מיילים ארוכים מדי, להסיר כפילויות לפני שאני מפצלת את הדאטה, לאזן ל-35% פישינג ריאליסטי — כי תיבות דואר אמיתיות הן ברובן לגיטימיות — ואז לפצל לאימון, ולידציה ומבחן ביחס 60/20/20 עם seed קבוע. seed זה פשוט מספר התחלה קבוע כדי שהפיצול האקראי ייצא זהה בכל פעם וכל אחד יוכל לשחזר את התוצאות שלי; ואני עושה hash לדאטה — hash זה כמו טביעת אצבע של הקובץ — כדי שאוכל להוכיח שהמספרים באו בדיוק מהדאטה הזה. הקופסה הזהובה היא הבחירה הכי חשובה שלי: הרצתי בדיקה מהירה וגיליתי שאפשר לנחש מאיזה מקור מייל הגיע ב-99% מהמקרים. אז אם הייתי מערבבת פישינג ממקור אחד עם דואר רגיל ממקור אחר, המודל היה 'מרמה' — הוא היה לומד לזהות את המקור במקום את ההונאה. לכן אני מאמנת על מקור מעורב אחד. ושתי בדיקות מהירות למטה: דואר רגיל הוא כמעט כולו טקסט פשוט, וזה הופך לבסיס הנקי שמתקפת האותיות שלי שוברת בהמשך; והתאריכים נקיים — אין תאריכי '1970' מזויפים, שזה מה שמקבלים כשתאריך חסר מתמלא באפס.</a:t>
             </a:r>
             <a:endParaRPr lang="en-US" dirty="0"/>
           </a:p>
@@ -7150,7 +7208,9 @@
           <a:p>
             <a:r>
               <a:rPr lang="en-US" dirty="0"/>
-              <a:t>Before modelling I explore a handful of simple, human-readable features — length, word count, digit ratio, share of non-standard characters — and check how they relate. This heatmap is those relationships. Two takeaways: length and word-count are nearly identical (they carry one signal, not two), and length is the feature most tied to the label — phishing emails are shorter, a quick urgent message versus a long legitimate one. I use rank correlation because the features are lopsided, and ranks aren't thrown off by outliers. Note: these features are just for understanding — the model's real power is in the words.</a:t>
+              <a:t>Before I build anything, I do EDA — exploratory data analysis. That just means getting to know the data first: looking at a few simple, human-understandable properties of each email, like its length, the number of words, how many digits it has, and how many unusual characters. This colourful grid is a correlation heatmap. Correlation measures how much two things move together: dark means they rise and fall together, pale means they don't really relate. Specifically I use Spearman rank correlation — 'rank' means I compare the ORDER of the values, not the raw values, which is safer when the data is lopsided or has a few extreme outliers, because one weird huge email can't distort it. Two things to read off it: length and word-count are almost the same thing — obviously, a longer email has more words, so they carry one signal, not two; and length is the property most connected to the phishing label, because phishing emails tend to be short and urgent while legitimate ones are often longer. One honest note: these simple features are just for understanding the data. The model's real power comes from the actual words, not these.
+— — —  עברית  — — —
+לפני שאני בונה משהו, אני עושה EDA — ניתוח נתונים חוקר. זה פשוט אומר להכיר קודם את הדאטה: להסתכל על כמה תכונות פשוטות שאדם יכול להבין של כל מייל, כמו האורך שלו, מספר המילים, כמה ספרות יש בו, וכמה תווים חריגים. הרשת הצבעונית הזאת היא מפת חום של קורלציה. קורלציה מודדת כמה שני דברים נעים יחד: כהה אומר שהם עולים ויורדים ביחד, בהיר אומר שהם לא ממש קשורים. ספציפית אני משתמשת בקורלציית דירוג של ספירמן (Spearman) — 'דירוג' אומר שאני משווה את הסדר של הערכים, לא את הערכים הגולמיים, וזה בטוח יותר כשהדאטה עקום או יש בו כמה חריגים קיצוניים, כי מייל ענק ומוזר אחד לא יכול לעוות אותו. שני דברים לקרוא מזה: אורך ומספר מילים הם כמעט אותו דבר — מובן מאליו, מייל ארוך יותר מכיל יותר מילים, אז הם נושאים אות אחד, לא שניים; והאורך הוא התכונה הכי קשורה לתווית הפישינג, כי מיילים של פישינג נוטים להיות קצרים ודחופים בעוד לגיטימיים לרוב ארוכים יותר. הערה כנה: התכונות הפשוטות האלה הן רק להבנת הדאטה. הכוח האמיתי של המודל מגיע מהמילים עצמן, לא מאלה.</a:t>
             </a:r>
             <a:endParaRPr lang="en-US" dirty="0"/>
           </a:p>
@@ -7238,7 +7298,9 @@
           <a:p>
             <a:r>
               <a:rPr lang="en-US" dirty="0"/>
-              <a:t>Two results to explain. Left: how each simple feature relates to being phishing. Length and word-count stand out and are negative — phishing is shorter and has fewer words. I didn't just eyeball a chart; a Mann–Whitney test confirms the length difference is real with p far below 0.001. Right: a redundancy check called VIF. Length and word-count both score around 21 — anything over 10 means they say the same thing — so I keep them as diagnostics and don't feed both to the model. This is standard EDA done properly: rank stats, a real test, and a redundancy check.</a:t>
+              <a:t>Two proper results here, not just eyeballing. The left chart shows how strongly each simple feature is linked to being phishing. Length and word-count stick out, and they're negative — the minus sign means: more length, less likely phishing. In other words phishing is shorter. But I didn't want to just say 'it looks shorter' — I ran a real statistical test called Mann–Whitney. All it does is check whether two groups — phishing versus legitimate — genuinely differ in length, or whether it could just be luck. It gives a p-value, which is the probability the difference is just chance; my p is far below 0.001, meaning less than a tenth of a percent chance it's a fluke, so the difference is real. The right chart is a redundancy check called VIF — variance inflation factor. It flags when two features basically say the same thing. Anything above 10 is a red flag; length and word-count both score around 21, confirming they're duplicates. So I keep them only as notes and I don't feed both into the model. The takeaway: this is textbook EDA done properly — rank statistics, a real hypothesis test, and a redundancy check.
+— — —  עברית  — — —
+שתי תוצאות אמיתיות כאן, לא רק הסתכלות בעין. הגרף השמאלי מראה כמה כל תכונה פשוטה קשורה לפישינג. אורך ומספר מילים בולטים, והם שליליים — סימן המינוס אומר: יותר אורך, פחות סיכוי לפישינג. במילים אחרות, פישינג קצר יותר. אבל לא רציתי רק לומר 'זה נראה קצר יותר' — הרצתי מבחן סטטיסטי אמיתי שנקרא מאן-וויטני (Mann–Whitney). כל מה שהוא עושה זה לבדוק אם שתי קבוצות — פישינג מול לגיטימי — באמת נבדלות באורך, או שזה יכול להיות סתם מזל. הוא נותן p-value, שזו ההסתברות שההבדל הוא רק מקרי; ה-p שלי הרבה מתחת ל-0.001, כלומר פחות מעשירית האחוז סיכוי שזה צירוף מקרים, אז ההבדל אמיתי. הגרף הימני הוא בדיקת יתירות שנקראת VIF. הוא מסמן כשתי תכונות בעצם אומרות אותו דבר. כל ערך מעל 10 הוא דגל אדום; אורך ומספר מילים שניהם בסביבות 21, מה שמאשר שהם כפילויות. אז אני שומרת אותם רק כהערות ולא מזינה את שניהם למודל. השורה התחתונה: זה EDA לפי הספר — סטטיסטיקת דירוג, מבחן השערה אמיתי, ובדיקת יתירות.</a:t>
             </a:r>
             <a:endParaRPr lang="en-US" dirty="0"/>
           </a:p>
@@ -7326,7 +7388,9 @@
           <a:p>
             <a:r>
               <a:rPr lang="en-US" dirty="0"/>
-              <a:t>Model choice, decided by results not taste. The two grey-left bars are trivial baselines: always-guess-legit and a keyword list — both weak, and the majority one is the accuracy paradox in action: it looks 65% accurate but catches zero phishing, which is why I never rely on accuracy. Then the real models: Naive Bayes variants, DistilBERT, and Logistic Regression, which wins at F1 0.998. Its lead is statistically real. I pick it because it's near-perfect, fast, and — importantly for the rest of the talk — explainable. DistilBERT is kept only as a baseline.</a:t>
+              <a:t>I didn't just pick a fancy model — I compared several and let the results decide. Start on the left with two 'baselines', which are deliberately dumb models I use as a floor to beat. The first always guesses 'legitimate'. It sounds silly, but it exposes something important called the accuracy paradox: because most email is legitimate, this do-nothing model is about 65% 'accurate' — yet it catches ZERO phishing. That's exactly why accuracy is a misleading score and I don't rely on it. The second baseline is a simple keyword list. Then the real models: Naive Bayes — a classic simple text classifier — DistilBERT, which is a small modern neural language model, and finally Logistic Regression, my choice, which wins with an F1 of 0.998. F1 is the score I trust instead of accuracy — I'll define it on the next slide, but for now: high F1 means it catches the phishing without crying wolf on normal mail. I checked its lead is statistically real, not luck. I pick Logistic Regression because it's near-perfect, very fast, and — crucial for the rest of this talk — explainable. DistilBERT I keep only as a comparison baseline.
+— — —  עברית  — — —
+לא סתם בחרתי מודל מפואר — השוויתי כמה ונתתי לתוצאות להחליט. מתחילים משמאל עם שני 'בסיסים' (baselines), שהם מודלים טיפשיים בכוונה שאני משתמשת בהם כרצפה לנצח. הראשון תמיד מנחש 'לגיטימי'. זה נשמע מטופש, אבל זה חושף משהו חשוב שנקרא פרדוקס הדיוק (accuracy paradox): מכיוון שרוב הדואר לגיטימי, המודל הזה שלא עושה כלום מגיע לדיוק של בערך 65% — ובכל זאת תופס אפס פישינג. בדיוק בגלל זה דיוק הוא ציון מטעה ואני לא נשענת עליו. הבסיס השני הוא רשימת מילות מפתח פשוטה. אחר כך המודלים האמיתיים: Naive Bayes — מסווג טקסט קלאסי ופשוט — DistilBERT, שהוא מודל שפה נוירוני מודרני קטן, ולבסוף Logistic Regression, הבחירה שלי, שמנצחת עם F1 של 0.998. F1 הוא הציון שאני סומכת עליו במקום דיוק — אגדיר אותו בשקף הבא, אבל בינתיים: F1 גבוה אומר שהוא תופס את הפישינג בלי להתריע לשווא על דואר רגיל. בדקתי שהיתרון שלה אמיתי סטטיסטית, לא מזל. בחרתי ב-Logistic Regression כי היא כמעט מושלמת, מהירה מאוד, ו — קריטי להמשך ההרצאה — ניתנת להסבר. את DistilBERT אני שומרת רק כבסיס להשוואה.</a:t>
             </a:r>
             <a:endParaRPr lang="en-US" dirty="0"/>
           </a:p>
@@ -9053,8 +9117,8 @@
         </p:nvSpPr>
         <p:spPr>
           <a:xfrm>
-            <a:off x="566928" y="4846320"/>
-            <a:ext cx="5120640" cy="1097280"/>
+            <a:off x="566928" y="4709160"/>
+            <a:ext cx="5120640" cy="1005840"/>
           </a:xfrm>
           <a:prstGeom prst="rect">
             <a:avLst/>
@@ -9087,6 +9151,59 @@
       <p:sp>
         <p:nvSpPr>
           <p:cNvPr id="32" name="Text 30"/>
+          <p:cNvSpPr/>
+          <p:nvPr/>
+        </p:nvSpPr>
+        <p:spPr>
+          <a:xfrm>
+            <a:off x="566928" y="5943600"/>
+            <a:ext cx="11057839" cy="292608"/>
+          </a:xfrm>
+          <a:prstGeom prst="rect">
+            <a:avLst/>
+          </a:prstGeom>
+          <a:noFill/>
+          <a:ln/>
+        </p:spPr>
+        <p:txBody>
+          <a:bodyPr wrap="square" rtlCol="0" anchor="ctr"/>
+          <a:lstStyle/>
+          <a:p>
+            <a:pPr indent="0" marL="0">
+              <a:buNone/>
+            </a:pPr>
+            <a:r>
+              <a:rPr lang="en-US" sz="1100" b="1" dirty="0">
+                <a:solidFill>
+                  <a:srgbClr val="95A6AD"/>
+                </a:solidFill>
+                <a:latin typeface="Courier New" pitchFamily="34" charset="0"/>
+                <a:ea typeface="Courier New" pitchFamily="34" charset="-122"/>
+                <a:cs typeface="Courier New" pitchFamily="34" charset="-120"/>
+              </a:rPr>
+              <a:t>F1 = 2·precision·recall / (precision + recall)</a:t>
+            </a:r>
+            <a:pPr indent="0" marL="0">
+              <a:buNone/>
+            </a:pPr>
+            <a:r>
+              <a:rPr lang="en-US" sz="1100" dirty="0">
+                <a:solidFill>
+                  <a:srgbClr val="6E7F87"/>
+                </a:solidFill>
+                <a:latin typeface="Calibri" pitchFamily="34" charset="0"/>
+                <a:ea typeface="Calibri" pitchFamily="34" charset="-122"/>
+                <a:cs typeface="Calibri" pitchFamily="34" charset="-120"/>
+              </a:rPr>
+              <a:t>    ·    MCC: a balanced score from −1 to +1, honest even when the classes are uneven</a:t>
+            </a:r>
+            <a:endParaRPr lang="en-US" sz="1100" dirty="0"/>
+          </a:p>
+        </p:txBody>
+      </p:sp>
+      <p:sp>
+        <p:nvSpPr>
+          <p:cNvPr id="33" name="Text 31"/>
           <p:cNvSpPr/>
           <p:nvPr/>
         </p:nvSpPr>
@@ -26104,6 +26221,139 @@
         </p:nvSpPr>
         <p:spPr>
           <a:xfrm>
+            <a:off x="566928" y="1536192"/>
+            <a:ext cx="11057839" cy="676656"/>
+          </a:xfrm>
+          <a:prstGeom prst="roundRect">
+            <a:avLst>
+              <a:gd name="adj" fmla="val 8108"/>
+            </a:avLst>
+          </a:prstGeom>
+          <a:solidFill>
+            <a:srgbClr val="1B2B32"/>
+          </a:solidFill>
+          <a:ln w="12700">
+            <a:solidFill>
+              <a:srgbClr val="26363D"/>
+            </a:solidFill>
+            <a:prstDash val="solid"/>
+          </a:ln>
+        </p:spPr>
+      </p:sp>
+      <p:sp>
+        <p:nvSpPr>
+          <p:cNvPr id="7" name="Text 5"/>
+          <p:cNvSpPr/>
+          <p:nvPr/>
+        </p:nvSpPr>
+        <p:spPr>
+          <a:xfrm>
+            <a:off x="768096" y="1600200"/>
+            <a:ext cx="10655503" cy="274320"/>
+          </a:xfrm>
+          <a:prstGeom prst="rect">
+            <a:avLst/>
+          </a:prstGeom>
+          <a:noFill/>
+          <a:ln/>
+        </p:spPr>
+        <p:txBody>
+          <a:bodyPr wrap="square" rtlCol="0" anchor="ctr"/>
+          <a:lstStyle/>
+          <a:p>
+            <a:pPr indent="0" marL="0">
+              <a:buNone/>
+            </a:pPr>
+            <a:r>
+              <a:rPr lang="en-US" sz="1350" b="1" dirty="0">
+                <a:solidFill>
+                  <a:srgbClr val="EAF0F1"/>
+                </a:solidFill>
+                <a:latin typeface="Courier New" pitchFamily="34" charset="0"/>
+                <a:ea typeface="Courier New" pitchFamily="34" charset="-122"/>
+                <a:cs typeface="Courier New" pitchFamily="34" charset="-120"/>
+              </a:rPr>
+              <a:t>TF-IDF(t, d) = tf(t, d) × log( N / df(t) )</a:t>
+            </a:r>
+            <a:pPr indent="0" marL="0">
+              <a:buNone/>
+            </a:pPr>
+            <a:r>
+              <a:rPr lang="en-US" sz="1150" dirty="0">
+                <a:solidFill>
+                  <a:srgbClr val="95A6AD"/>
+                </a:solidFill>
+                <a:latin typeface="Calibri" pitchFamily="34" charset="0"/>
+                <a:ea typeface="Calibri" pitchFamily="34" charset="-122"/>
+                <a:cs typeface="Calibri" pitchFamily="34" charset="-120"/>
+              </a:rPr>
+              <a:t>   a word's weight — how often it appears in this email, lowered if it appears in every email</a:t>
+            </a:r>
+            <a:endParaRPr lang="en-US" sz="1350" dirty="0"/>
+          </a:p>
+        </p:txBody>
+      </p:sp>
+      <p:sp>
+        <p:nvSpPr>
+          <p:cNvPr id="8" name="Text 6"/>
+          <p:cNvSpPr/>
+          <p:nvPr/>
+        </p:nvSpPr>
+        <p:spPr>
+          <a:xfrm>
+            <a:off x="768096" y="1892808"/>
+            <a:ext cx="10655503" cy="274320"/>
+          </a:xfrm>
+          <a:prstGeom prst="rect">
+            <a:avLst/>
+          </a:prstGeom>
+          <a:noFill/>
+          <a:ln/>
+        </p:spPr>
+        <p:txBody>
+          <a:bodyPr wrap="square" rtlCol="0" anchor="ctr"/>
+          <a:lstStyle/>
+          <a:p>
+            <a:pPr indent="0" marL="0">
+              <a:buNone/>
+            </a:pPr>
+            <a:r>
+              <a:rPr lang="en-US" sz="1350" b="1" dirty="0">
+                <a:solidFill>
+                  <a:srgbClr val="EAF0F1"/>
+                </a:solidFill>
+                <a:latin typeface="Courier New" pitchFamily="34" charset="0"/>
+                <a:ea typeface="Courier New" pitchFamily="34" charset="-122"/>
+                <a:cs typeface="Courier New" pitchFamily="34" charset="-120"/>
+              </a:rPr>
+              <a:t>score = σ(w·x + b),   σ(z) = 1 / (1 + e^−z)</a:t>
+            </a:r>
+            <a:pPr indent="0" marL="0">
+              <a:buNone/>
+            </a:pPr>
+            <a:r>
+              <a:rPr lang="en-US" sz="1150" dirty="0">
+                <a:solidFill>
+                  <a:srgbClr val="95A6AD"/>
+                </a:solidFill>
+                <a:latin typeface="Calibri" pitchFamily="34" charset="0"/>
+                <a:ea typeface="Calibri" pitchFamily="34" charset="-122"/>
+                <a:cs typeface="Calibri" pitchFamily="34" charset="-120"/>
+              </a:rPr>
+              <a:t>   add each word's weight × its TF-IDF, then squash to a probability between 0 and 1</a:t>
+            </a:r>
+            <a:endParaRPr lang="en-US" sz="1350" dirty="0"/>
+          </a:p>
+        </p:txBody>
+      </p:sp>
+      <p:sp>
+        <p:nvSpPr>
+          <p:cNvPr id="9" name="Shape 7"/>
+          <p:cNvSpPr/>
+          <p:nvPr/>
+        </p:nvSpPr>
+        <p:spPr>
+          <a:xfrm>
             <a:off x="566928" y="2331720"/>
             <a:ext cx="1965960" cy="1371600"/>
           </a:xfrm>
@@ -26125,7 +26375,7 @@
       </p:sp>
       <p:sp>
         <p:nvSpPr>
-          <p:cNvPr id="7" name="Text 5"/>
+          <p:cNvPr id="10" name="Text 8"/>
           <p:cNvSpPr/>
           <p:nvPr/>
         </p:nvSpPr>
@@ -26198,7 +26448,7 @@
       </p:sp>
       <p:sp>
         <p:nvSpPr>
-          <p:cNvPr id="8" name="Text 6"/>
+          <p:cNvPr id="11" name="Text 9"/>
           <p:cNvSpPr/>
           <p:nvPr/>
         </p:nvSpPr>
@@ -26237,7 +26487,7 @@
       </p:sp>
       <p:sp>
         <p:nvSpPr>
-          <p:cNvPr id="9" name="Shape 7"/>
+          <p:cNvPr id="12" name="Shape 10"/>
           <p:cNvSpPr/>
           <p:nvPr/>
         </p:nvSpPr>
@@ -26264,7 +26514,7 @@
       </p:sp>
       <p:sp>
         <p:nvSpPr>
-          <p:cNvPr id="10" name="Text 8"/>
+          <p:cNvPr id="13" name="Text 11"/>
           <p:cNvSpPr/>
           <p:nvPr/>
         </p:nvSpPr>
@@ -26337,7 +26587,7 @@
       </p:sp>
       <p:sp>
         <p:nvSpPr>
-          <p:cNvPr id="11" name="Text 9"/>
+          <p:cNvPr id="14" name="Text 12"/>
           <p:cNvSpPr/>
           <p:nvPr/>
         </p:nvSpPr>
@@ -26376,7 +26626,7 @@
       </p:sp>
       <p:sp>
         <p:nvSpPr>
-          <p:cNvPr id="12" name="Shape 10"/>
+          <p:cNvPr id="15" name="Shape 13"/>
           <p:cNvSpPr/>
           <p:nvPr/>
         </p:nvSpPr>
@@ -26403,7 +26653,7 @@
       </p:sp>
       <p:sp>
         <p:nvSpPr>
-          <p:cNvPr id="13" name="Text 11"/>
+          <p:cNvPr id="16" name="Text 14"/>
           <p:cNvSpPr/>
           <p:nvPr/>
         </p:nvSpPr>
@@ -26476,7 +26726,7 @@
       </p:sp>
       <p:sp>
         <p:nvSpPr>
-          <p:cNvPr id="14" name="Text 12"/>
+          <p:cNvPr id="17" name="Text 15"/>
           <p:cNvSpPr/>
           <p:nvPr/>
         </p:nvSpPr>
@@ -26515,7 +26765,7 @@
       </p:sp>
       <p:sp>
         <p:nvSpPr>
-          <p:cNvPr id="15" name="Shape 13"/>
+          <p:cNvPr id="18" name="Shape 16"/>
           <p:cNvSpPr/>
           <p:nvPr/>
         </p:nvSpPr>
@@ -26542,7 +26792,7 @@
       </p:sp>
       <p:sp>
         <p:nvSpPr>
-          <p:cNvPr id="16" name="Text 14"/>
+          <p:cNvPr id="19" name="Text 17"/>
           <p:cNvSpPr/>
           <p:nvPr/>
         </p:nvSpPr>
@@ -26615,7 +26865,7 @@
       </p:sp>
       <p:sp>
         <p:nvSpPr>
-          <p:cNvPr id="17" name="Text 15"/>
+          <p:cNvPr id="20" name="Text 18"/>
           <p:cNvSpPr/>
           <p:nvPr/>
         </p:nvSpPr>
@@ -26654,7 +26904,7 @@
       </p:sp>
       <p:sp>
         <p:nvSpPr>
-          <p:cNvPr id="18" name="Shape 16"/>
+          <p:cNvPr id="21" name="Shape 19"/>
           <p:cNvSpPr/>
           <p:nvPr/>
         </p:nvSpPr>
@@ -26681,7 +26931,7 @@
       </p:sp>
       <p:sp>
         <p:nvSpPr>
-          <p:cNvPr id="19" name="Text 17"/>
+          <p:cNvPr id="22" name="Text 20"/>
           <p:cNvSpPr/>
           <p:nvPr/>
         </p:nvSpPr>
@@ -26771,7 +27021,7 @@
       </p:sp>
       <p:sp>
         <p:nvSpPr>
-          <p:cNvPr id="20" name="Shape 18"/>
+          <p:cNvPr id="23" name="Shape 21"/>
           <p:cNvSpPr/>
           <p:nvPr/>
         </p:nvSpPr>
@@ -26798,7 +27048,7 @@
       </p:sp>
       <p:sp>
         <p:nvSpPr>
-          <p:cNvPr id="21" name="Shape 19"/>
+          <p:cNvPr id="24" name="Shape 22"/>
           <p:cNvSpPr/>
           <p:nvPr/>
         </p:nvSpPr>
@@ -26818,7 +27068,7 @@
       </p:sp>
       <p:sp>
         <p:nvSpPr>
-          <p:cNvPr id="22" name="Text 20"/>
+          <p:cNvPr id="25" name="Text 23"/>
           <p:cNvSpPr/>
           <p:nvPr/>
         </p:nvSpPr>
@@ -26857,7 +27107,7 @@
       </p:sp>
       <p:sp>
         <p:nvSpPr>
-          <p:cNvPr id="23" name="Shape 21"/>
+          <p:cNvPr id="26" name="Shape 24"/>
           <p:cNvSpPr/>
           <p:nvPr/>
         </p:nvSpPr>
@@ -26884,7 +27134,7 @@
       </p:sp>
       <p:sp>
         <p:nvSpPr>
-          <p:cNvPr id="24" name="Shape 22"/>
+          <p:cNvPr id="27" name="Shape 25"/>
           <p:cNvSpPr/>
           <p:nvPr/>
         </p:nvSpPr>
@@ -26904,7 +27154,7 @@
       </p:sp>
       <p:sp>
         <p:nvSpPr>
-          <p:cNvPr id="25" name="Text 23"/>
+          <p:cNvPr id="28" name="Text 26"/>
           <p:cNvSpPr/>
           <p:nvPr/>
         </p:nvSpPr>
@@ -26943,7 +27193,7 @@
       </p:sp>
       <p:sp>
         <p:nvSpPr>
-          <p:cNvPr id="26" name="Shape 24"/>
+          <p:cNvPr id="29" name="Shape 27"/>
           <p:cNvSpPr/>
           <p:nvPr/>
         </p:nvSpPr>
@@ -26970,7 +27220,7 @@
       </p:sp>
       <p:sp>
         <p:nvSpPr>
-          <p:cNvPr id="27" name="Shape 25"/>
+          <p:cNvPr id="30" name="Shape 28"/>
           <p:cNvSpPr/>
           <p:nvPr/>
         </p:nvSpPr>
@@ -26990,7 +27240,7 @@
       </p:sp>
       <p:sp>
         <p:nvSpPr>
-          <p:cNvPr id="28" name="Text 26"/>
+          <p:cNvPr id="31" name="Text 29"/>
           <p:cNvSpPr/>
           <p:nvPr/>
         </p:nvSpPr>
@@ -27029,7 +27279,7 @@
       </p:sp>
       <p:sp>
         <p:nvSpPr>
-          <p:cNvPr id="29" name="Text 27"/>
+          <p:cNvPr id="32" name="Text 30"/>
           <p:cNvSpPr/>
           <p:nvPr/>
         </p:nvSpPr>
@@ -27082,7 +27332,7 @@
       </p:sp>
       <p:sp>
         <p:nvSpPr>
-          <p:cNvPr id="30" name="Text 28"/>
+          <p:cNvPr id="33" name="Text 31"/>
           <p:cNvSpPr/>
           <p:nvPr/>
         </p:nvSpPr>

</xml_diff>

<commit_message>
Presentation: name Levenshtein distance (slide 14) + sentiment as considered feature (slide 24)
- Slide 14: budget caption now names it Levenshtein/edit distance with a
  one-line definition; note explains edit distance and the k-bound
- Slide 24 (LLM section): bottom line now flags a considered hand-crafted
  sentiment/emotion feature (urgency/fear/reward via LLM or VADER lexicon),
  honestly noting redundancy with TF-IDF; caveats moved into the note
</commit_message>
<xml_diff>
--- a/presentation/PhishFusion_presentation_dark.pptx
+++ b/presentation/PhishFusion_presentation_dark.pptx
@@ -4211,13 +4211,13 @@
               <c:strCache>
                 <c:ptCount val="3"/>
                 <c:pt idx="0">
-                  <c:v>standard diluted</c:v>
+                  <c:v>standard, under padding attack</c:v>
                 </c:pt>
                 <c:pt idx="1">
-                  <c:v>one-way diluted</c:v>
+                  <c:v>monotone under attack</c:v>
                 </c:pt>
                 <c:pt idx="2">
-                  <c:v>one-way clean F1</c:v>
+                  <c:v>monotone, no attack F1</c:v>
                 </c:pt>
               </c:strCache>
             </c:strRef>
@@ -4917,13 +4917,17 @@
               <a:t>This slide compares two defences against the letter attack, and I want to explain the three bar-groups, especially the last one, 'adaptive'. The first group, 'homoglyph (seen)', is the exact attack the model already knows. The second, 'full-width (unseen)', is a related attack it was NOT trained on — a fairness test. The third, 'adaptive', means an attacker who KNOWS my defence exists and deliberately adapts to get around it — for example using look-alike characters my cleaner doesn't cover, or mixing several tricks together. That's why its numbers are a bit lower than the others: it's the hardest case, an opponent actively fighting the defence rather than a fixed attack. THE FIX, in teal, is normalisation — folding look-alike letters back to plain ones before classifying — and even against the adaptive attacker it still holds around 0.96. The amber bars are adversarial training, which memorises the attack it was shown but is weaker on the unseen one, only 0.78. THE LESSON: a principled defence generalises to new attacks; a memorised one only knows what it saw. Used together they cover every family.</a:t>
             </a:r>
           </a:p>
-          <a:p/>
+          <a:p>
+            <a:endParaRPr/>
+          </a:p>
           <a:p>
             <a:r>
               <a:t>— — —  עברית  — — —</a:t>
             </a:r>
           </a:p>
-          <a:p/>
+          <a:p>
+            <a:endParaRPr/>
+          </a:p>
           <a:p>
             <a:r>
               <a:t>השקף הזה משווה שתי הגנות מול מתקפת האותיות, ואני רוצה להסביר את שלוש קבוצות העמודות, במיוחד את האחרונה, 'adaptive'. הקבוצה הראשונה, 'homoglyph (seen)', היא המתקפה המדויקת שהמודל כבר מכיר. השנייה, 'full-width (unseen)', היא מתקפה קרובה שהוא לא אומן עליה — מבחן הוגנות. השלישית, 'adaptive' (אדפטיבית), אומרת תוקף שיודע שההגנה שלי קיימת ומתאים את עצמו בכוונה כדי לעקוף אותה — למשל תווי-כפילות שהמנקה שלי לא מכסה, או ערבוב של כמה טריקים יחד. לכן המספרים שלה קצת נמוכים יותר מהשאר: זה המקרה הכי קשה, יריב שנלחם באופן פעיל בהגנה ולא מתקפה קבועה. THE FIX, בטורקיז, היא נורמליזציה — החזרת אותיות דומות לאותיות רגילות לפני הסיווג — וגם מול התוקף האדפטיבי היא עדיין מחזיקה בסביבות 0.96. העמודות בענבר הן אימון יריב, שמשנן את המתקפה שהראו לו אבל חלש יותר על זו שלא ראה, רק 0.78. THE LESSON: הגנה עקרונית מתכללת למתקפות חדשות; הגנה משוננת יודעת רק את מה שראתה. יחד הן מכסות כל משפחה.</a:t>
@@ -5012,10 +5016,19 @@
           <a:lstStyle/>
           <a:p>
             <a:r>
-              <a:rPr lang="en-US" dirty="0"/>
-              <a:t>Now I make the attacker smarter, because a real criminal wouldn't attack randomly. THE ATTACK: instead of changing random letters, the attacker first works out which words my model relies on most — the highest-weight words — and only disguises those. This is called an importance-guided or adaptive attack, and it's a known family with names like DeepWordBug and TextBugger. It also uses look-alike characters that my hand-made cleaning list happened to miss — because my list was incomplete. THE RESULT: with the exact same budget, 8 edits, aiming them cleverly drops recall to 0.74, versus 0.98 when the same 8 edits are random. A typical email flips from 'phishing' to 'safe' after only 9 invisible edits — about a quarter of its letters. And even my fully-defended model gets pulled down to 0.88. This is the honest 'there is no silver bullet' moment: a capable, thoughtful attacker found the gap. Which sets up the next slide, where I close it for good.
-— — —  עברית  — — —
-עכשיו אני הופכת את התוקף לחכם יותר, כי פושע אמיתי לא היה תוקף באקראי. THE ATTACK: במקום לשנות אותיות אקראיות, התוקף קודם מגלה על אילו מילים המודל שלי הכי נשען — המילים עם המשקל הגבוה ביותר — ומחפש רק אותן. זה נקרא מתקפה מונחית-חשיבות או אדפטיבית, וזו משפחה מוכרת עם שמות כמו DeepWordBug ו-TextBugger. היא גם משתמשת בתווי כפילות שהרשימה הידנית שלי פספסה — כי הרשימה שלי לא הייתה שלמה. THE RESULT: עם אותו תקציב בדיוק, 8 שינויים, כיוון חכם שלהם מוריד את ה-recall ל-0.74, לעומת 0.98 כשאותם 8 שינויים אקראיים. מייל טיפוסי מתהפך מ'פישינג' ל'בטוח' אחרי רק 9 שינויים בלתי-נראים — בערך רבע מהאותיות שלו. ואפילו המודל המוגן לגמרי שלי נמשך למטה ל-0.88. זה הרגע הכן של 'אין פתרון קסם': תוקף מוכשר וחושב מצא את הפרצה. וזה מכין את השקף הבא, שבו אני סוגרת אותה סופית.</a:t>
+              <a:t>Now I make the attacker smarter, because a real criminal wouldn't attack randomly. THE ATTACK: instead of changing random letters, the attacker first works out which words my model relies on most — the highest-weight words — and only disguises those. This is called an importance-guided or adaptive attack, a known family with names like DeepWordBug and TextBugger, and it uses look-alike characters my hand-made list happened to miss. THE RESULT: with the same budget, 8 edits, aiming them cleverly drops recall to 0.74, versus 0.98 when the same 8 edits are random; a typical email flips after only 9 invisible edits, and even my fully-defended model drops to 0.88. Quick note on that word 'edits', because I keep using it: the number of edits is a real metric called the Levenshtein distance, or edit distance — the smallest number of single-character insertions, deletions or substitutions needed to turn one piece of text into another. So '8 edits' means the attacker is allowed a Levenshtein distance of 8, and the email flips at a distance of about 9. Bounding the attacker by edit distance is the standard way the adversarial-text papers measure how big a perturbation is. This is the honest 'no silver bullet' moment — a capable attacker found the gap — which sets up the next slide where I close it for good.</a:t>
+            </a:r>
+          </a:p>
+          <a:p/>
+          <a:p>
+            <a:r>
+              <a:t>— — —  עברית  — — —</a:t>
+            </a:r>
+          </a:p>
+          <a:p/>
+          <a:p>
+            <a:r>
+              <a:t>עכשיו אני הופכת את התוקף לחכם יותר, כי פושע אמיתי לא היה תוקף באקראי. THE ATTACK: במקום לשנות אותיות אקראיות, התוקף קודם מגלה על אילו מילים המודל שלי הכי נשען — המילים עם המשקל הגבוה — ומחפש רק אותן. זה נקרא מתקפה מונחית-חשיבות או אדפטיבית, משפחה מוכרת עם שמות כמו DeepWordBug ו-TextBugger, והיא משתמשת בתווי-כפילות שהרשימה הידנית שלי פספסה. THE RESULT: עם אותו תקציב, 8 שינויים, כיוון חכם מוריד את ה-recall ל-0.74, לעומת 0.98 כשאותם 8 שינויים אקראיים; מייל טיפוסי מתהפך אחרי רק 9 שינויים בלתי-נראים, ואפילו המודל המוגן לגמרי יורד ל-0.88. הערה מהירה על המילה 'שינויים' (edits), כי אני חוזרת עליה: מספר השינויים הוא מדד אמיתי שנקרא מרחק לוינשטיין (Levenshtein), או מרחק עריכה — המספר הקטן ביותר של הכנסות, מחיקות או החלפות של תו בודד כדי להפוך טקסט אחד לאחר. אז '8 שינויים' אומר שהתוקף מורשה מרחק לוינשטיין של 8, והמייל מתהפך במרחק של בערך 9. הגבלת התוקף לפי מרחק עריכה היא הדרך הסטנדרטית שבה מאמרי הטקסט היריב מודדים כמה גדול השיבוש. זה הרגע הכן של 'אין פתרון קסם' — תוקף מוכשר מצא את הפרצה — וזה מכין את השקף הבא שבו אני סוגרת אותה סופית.</a:t>
             </a:r>
           </a:p>
         </p:txBody>
@@ -5104,13 +5117,17 @@
               <a:t>Here's the fix, and it comes with a mathematical guarantee. THE FIX: my earlier hand-made list of look-alike letters was incomplete, so I replace it with the FULL official list — a published standard called Unicode UTS #39, the same list browsers use to catch fake website addresses. Every letter the attacker sneaked through is on it. THE RESULT: recall against the smart attacker goes right back to 0.998. And the big 100% is a certificate — a proof, not just 'it worked on my tests': I can prove that after cleaning, the attacked email turns back into exactly the original text for 100% of phishing, so the decision cannot change. One thing I want to be crystal clear about, because people ask: this whole attack is still at the CHARACTER level — swapping or disguising letters, like 'ver1fy' or the Cyrillic look-alikes. It is NOT replacing a word with a synonym. Word-level attacks come later — the dilution attack that pads with extra words, and the LLM paraphrase that rewrites the wording. So this certificate specifically guarantees safety against letter tricks.</a:t>
             </a:r>
           </a:p>
-          <a:p/>
+          <a:p>
+            <a:endParaRPr/>
+          </a:p>
           <a:p>
             <a:r>
               <a:t>— — —  עברית  — — —</a:t>
             </a:r>
           </a:p>
-          <a:p/>
+          <a:p>
+            <a:endParaRPr/>
+          </a:p>
           <a:p>
             <a:r>
               <a:t>הנה התיקון, והוא מגיע עם הבטחה מתמטית. THE FIX: הרשימה הידנית הקודמת שלי של אותיות דומות הייתה חלקית, אז אני מחליפה אותה ברשימה הרשמית המלאה — תקן מפורסם שנקרא Unicode UTS #39, אותה רשימה שדפדפנים משתמשים בה כדי לתפוס כתובות אתרים מזויפות. כל אות שהתוקף הבריח נמצאת בה. THE RESULT: ה-recall מול התוקף החכם חוזר ישר ל-0.998. וה-100% הגדול הוא תעודה — הוכחה, לא רק 'זה עבד לי בבדיקות': אני יכולה להוכיח שאחרי הניקוי המייל המותקף חוזר להיות בדיוק הטקסט המקורי עבור 100% מהפישינג, אז ההחלטה לא יכולה להשתנות. דבר אחד שאני רוצה להבהיר לגמרי, כי שואלים: כל המתקפה הזאת היא עדיין ברמת התו — החלפה או הסוואה של אותיות, כמו 'ver1fy' או הכפילויות הקיריליות. זו לא החלפה של מילה במילה נרדפת. מתקפות ברמת המילה מגיעות בהמשך — מתקפת הדילול שמוסיפה מילים, ומתקפת הפרפרזה של ה-LLM שכותבת מחדש את הניסוח. אז התעודה הזאת מבטיחה ספציפית חסינות מפני טריקי-אותיות.</a:t>
@@ -5202,13 +5219,17 @@
               <a:t>Since I closed the letter tricks with a proof, the attacker changes strategy — from letters to whole words. THE ATTACK is the classic 'good-word attack', or dilution (Lowd &amp; Meek 2005): take the phishing email and pad it with lots of innocent, normal-sounding words. It works because my model is a 'bag-of-words' — it basically adds up evidence word by word and ignores order — so enough innocent words out-vote the few scam words and the total tips to 'safe'. THE RESULT, the red line: as I add filler, recall collapses from 0.998 down to 0.13, and my letter-cleaner does nothing here because it's a totally different kind of attack. The teal line, which barely moves, is my fix — the one-way, or 'monotone', model. Quick definition, since the word appears here: monotone just means the model is built so every word can only ADD suspicion, never subtract it. So adding text can only push the score up, and padding can't lower it below the line. That's why the teal line stays flat while the red one falls. I explain how I build it on the next slide.</a:t>
             </a:r>
           </a:p>
-          <a:p/>
+          <a:p>
+            <a:endParaRPr/>
+          </a:p>
           <a:p>
             <a:r>
               <a:t>— — —  עברית  — — —</a:t>
             </a:r>
           </a:p>
-          <a:p/>
+          <a:p>
+            <a:endParaRPr/>
+          </a:p>
           <a:p>
             <a:r>
               <a:t>מכיוון שסגרתי את טריקי-האותיות בהוכחה, התוקף משנה אסטרטגיה — מאותיות למילים שלמות. THE ATTACK היא 'מתקפת המילים הטובות' הקלאסית, או דילול (Lowd &amp; Meek 2005): לוקחים את מייל הפישינג וממלאים אותו בהמון מילים תמימות ונורמליות. זה עובד כי המודל שלי הוא 'שק של מילים' (bag-of-words) — הוא בעצם מחבר ראיות מילה-מילה ומתעלם מהסדר — אז מספיק מילים תמימות גוברות על מעט מילות ההונאה והסך הכל נוטה ל'בטוח'. THE RESULT, הקו האדום: ככל שאני מוסיפה מילוי, ה-recall קורס מ-0.998 ל-0.13, ומנקה-האותיות שלי לא עוזר כאן כי זו מתקפה מסוג אחר לגמרי. הקו הטורקיז, שכמעט לא זז, הוא התיקון שלי — המודל החד-כיווני, או 'מונוטוני' (monotone). הגדרה מהירה, כי המילה מופיעה כאן: מונוטוני פשוט אומר שהמודל בנוי כך שכל מילה יכולה רק להוסיף חשד, לעולם לא להחסיר. אז הוספת טקסט יכולה רק לדחוף את הציון למעלה, ומילוי לא יכול להוריד אותו מתחת לקו. לכן הקו הטורקיז נשאר שטוח בזמן שהאדום נופל. אני מסבירה איך אני בונה אותו בשקף הבא.</a:t>
@@ -5657,13 +5678,17 @@
               <a:t>Now two reality checks, because a lab score can be misleading. This first one is about SPACE — a different inbox. Up to now I trained and tested on the same dataset. Here I train on my dataset but test on completely different email collections, and F1 falls hard, from 0.998 to 0.37. I want to be very clear what 'different sources' means, because it's easy to misread: it means other email DATASETS — Nazario, Enron, Ling, SpamAssassin — not a different attack. These are ordinary, clean, un-attacked emails; the only thing that changed is which collection they came from. That gap is called distribution shift, or out-of-distribution — the new data just doesn't look like what the model learned from. And 0.37 is the honest number for the messy real world, not the flattering 0.998 from the lab. But I diagnose it rather than just report it: the AUC ranking score is still 0.78 on the new data, so the model isn't broken, just set to the wrong sensitivity — re-tuning that one threshold recovers F1 to 0.75. What genuinely remains is a vocabulary gap: the share of words the model has never seen jumps from 7% to 20%. So the scary 0.37 overstates the damage, but a real gap remains — which is the argument for retraining on fresh mail and for fusing with Gilad.</a:t>
             </a:r>
           </a:p>
-          <a:p/>
+          <a:p>
+            <a:endParaRPr/>
+          </a:p>
           <a:p>
             <a:r>
               <a:t>— — —  עברית  — — —</a:t>
             </a:r>
           </a:p>
-          <a:p/>
+          <a:p>
+            <a:endParaRPr/>
+          </a:p>
           <a:p>
             <a:r>
               <a:t>עכשיו שתי בדיקות מציאות, כי ציון מעבדה יכול להטעות. הראשונה היא על מרחב — תיבת דואר אחרת. עד עכשיו אימנתי ובדקתי על אותו דאטהסט. כאן אני מאמנת על הדאטהסט שלי אבל בודקת על אוספי מיילים שונים לגמרי, וה-F1 יורד חזק, מ-0.998 ל-0.37. אני רוצה להיות מאוד ברורה מה זה 'מקורות שונים', כי קל לטעות בזה: זה אומר דאטהסטים אחרים של מיילים — Nazario, Enron, Ling, SpamAssassin — לא מתקפה אחרת. אלה מיילים רגילים, נקיים, לא-מותקפים; הדבר היחיד שהשתנה הוא מאיזה אוסף הם הגיעו. הפער הזה נקרא הסחת התפלגות (distribution shift), או out-of-distribution — הדאטה החדש פשוט לא נראה כמו מה שהמודל למד ממנו. ו-0.37 הוא המספר הכן לעולם האמיתי הבלגני, לא ה-0.998 המחמיא מהמעבדה. אבל אני מאבחנת אותו ולא רק מדווחת: ציון הדירוג AUC עדיין 0.78 על הדאטה החדש, אז המודל לא שבור, רק מכוון לרגישות הלא נכונה — כיוונון מחדש של הסף האחד הזה מחזיר את ה-F1 ל-0.75. מה שבאמת נשאר זה פער אוצר-מילים: החלק של המילים שהמודל לא ראה מעולם קופץ מ-7% ל-20%. אז ה-0.37 המפחיד מגזים בנזק, אבל פער אמיתי נשאר — וזה הטיעון לאימון מחדש על דואר טרי ולמיזוג עם גלעד.</a:t>
@@ -6022,10 +6047,19 @@
           <a:lstStyle/>
           <a:p>
             <a:r>
-              <a:rPr lang="en-US" dirty="0"/>
-              <a:t>This is an extra idea I explored, and it probes the one attack that's still open. The attack: instead of tricking letters or padding words, I ask an LLM — a large language model like ChatGPT — to rewrite the whole scam in fresh words while keeping the same meaning. That's a paraphrase attack. But there's a catch: a rewrite might accidentally stop being a scam, and then it wouldn't be fair to call it an evasion. So I use a second, independent LLM as a judge to check that each rewrite is still genuinely phishing before I count it. That technique is called 'LLM-as-a-judge', and it kept 24 of the 30 rewrites. The result: my main model shrugs it off — recall stays 1.0 — because it has lots of overlapping word and character clues, so changing the wording doesn't remove all of them. My one-way safety-net model gives a little ground, 0.75 to 0.71, which is the honest downside of its guarantee, since it deliberately ignores 'innocent' evidence. I'm upfront about the caveats: the sample is small, the attacker and the judge are from the same AI family, and I froze the outputs so the experiment reproduces.
-— — —  עברית  — — —
-זה רעיון נוסף שחקרתי, והוא בוחן את המתקפה האחת שעדיין פתוחה. המתקפה: במקום לרמות אותיות או למלא מילים, אני מבקשת ממודל שפה גדול — LLM כמו ChatGPT — לכתוב מחדש את כל ההונאה במילים חדשות תוך שמירה על אותה משמעות. זו מתקפת פרפרזה (paraphrase). אבל יש מלכוד: כתיבה מחדש עלולה בטעות להפסיק להיות הונאה, ואז לא הוגן לקרוא לזה התחמקות. אז אני משתמשת ב-LLM שני ועצמאי כשופט כדי לבדוק שכל כתיבה מחדש עדיין באמת פישינג לפני שאני סופרת אותה. הטכניקה הזאת נקראת 'LLM-as-a-judge', והיא שמרה 24 מתוך 30 הכתיבות מחדש. התוצאה: המודל הראשי שלי לא מתרגש — ה-recall נשאר 1.0 — כי יש לו הרבה רמזי מילים ותווים חופפים, אז שינוי הניסוח לא מסיר את כולם. מודל רשת-הביטחון החד-כיווני שלי מוותר קצת, 0.75 ל-0.71, וזה החיסרון הכן של ההבטחה שלו, כי הוא בכוונה מתעלם מראיות 'תמימות'. אני שקופה לגבי ההסתייגויות: המדגם קטן, התוקף והשופט הם מאותה משפחת AI, והקפאתי את הפלטים כדי שהניסוי ישתחזר.</a:t>
+              <a:t>This is an extra idea I explored, and it probes the one attack that's still open. The attack: instead of tricking letters or padding words, I ask an LLM — a large language model like ChatGPT — to rewrite the whole scam in fresh words while keeping the same meaning. That's a paraphrase attack. There's a catch: a rewrite might accidentally stop being a scam, so I use a second, independent LLM as a judge to check each rewrite is still genuinely phishing before I count it — that's 'LLM-as-a-judge', and it kept 24 of 30. The result: my main model shrugs it off, recall stays 1.0, because it has lots of overlapping word and character clues; my one-way safety-net model gives a little ground, 0.75 to 0.71. The caveats: the sample is small, the attacker and judge are from the same AI family, and I froze the outputs so it reproduces. And the bottom line on the slide is a related idea I considered but did not put in the core model: a hand-crafted sentiment or emotion feature. The intuition is that phishing leans on emotional pressure — urgency, fear, reward — so I thought about scoring that, either with an LLM or a cheaper word-lexicon like VADER, and feeding it as an extra signal. Being honest, I expect it to add little, because my TF-IDF model already learns the emotional words directly, and plain positive-versus-negative sentiment doesn't cleanly separate phishing from ordinary marketing mail. So I keep it as future work — best aimed at urgency cues rather than raw polarity, and computed after normalisation so it survives the letter attacks.</a:t>
+            </a:r>
+          </a:p>
+          <a:p/>
+          <a:p>
+            <a:r>
+              <a:t>— — —  עברית  — — —</a:t>
+            </a:r>
+          </a:p>
+          <a:p/>
+          <a:p>
+            <a:r>
+              <a:t>זה רעיון נוסף שחקרתי, והוא בוחן את המתקפה האחת שעדיין פתוחה. המתקפה: במקום לרמות אותיות או למלא מילים, אני מבקשת ממודל שפה גדול — LLM כמו ChatGPT — לכתוב מחדש את כל ההונאה במילים חדשות תוך שמירה על אותה משמעות. זו מתקפת פרפרזה. יש מלכוד: כתיבה מחדש עלולה בטעות להפסיק להיות הונאה, אז אני משתמשת ב-LLM שני ועצמאי כשופט כדי לבדוק שכל כתיבה מחדש עדיין באמת פישינג לפני שאני סופרת אותה — זה 'LLM-as-a-judge', והוא שמר 24 מתוך 30. התוצאה: המודל הראשי שלי לא מתרגש, ה-recall נשאר 1.0, כי יש לו הרבה רמזי מילים ותווים חופפים; מודל רשת-הביטחון החד-כיווני שלי מוותר קצת, 0.75 ל-0.71. ההסתייגויות: המדגם קטן, התוקף והשופט מאותה משפחת AI, והקפאתי את הפלטים כדי שישתחזר. והשורה התחתונה בשקף היא רעיון קשור ששקלתי אבל לא הכנסתי למודל הליבה: תכונת סנטימנט או רגש בעבודת-יד. האינטואיציה היא שפישינג נשען על לחץ רגשי — דחיפות, פחד, פרס — אז חשבתי לתת לזה ציון, בעזרת LLM או לקסיקון מילים זול יותר כמו VADER, ולהזין אותו כאות נוסף. בכנות, אני מצפה שזה יוסיף מעט, כי מודל ה-TF-IDF שלי כבר לומד את המילים הרגשיות ישירות, וסנטימנט חיובי-מול-שלילי פשוט לא מפריד היטב בין פישינג לדואר שיווקי רגיל. אז אני שומרת את זה כעבודה עתידית — הכי טוב לכוון לרמזי דחיפות ולא לקוטביות גולמית, ולחשב אחרי נורמליזציה כדי שזה ישרוד את מתקפות האותיות.</a:t>
             </a:r>
           </a:p>
         </p:txBody>
@@ -6652,13 +6686,17 @@
               <a:t>This slide shows that the attacks and defences aren't things I invented — they come straight from the course's own taxonomy, the framework we were taught for organising adversarial machine learning. Let me walk through it box by box. Top-left, the attack taxonomy: attacks are grouped by WHEN and HOW they strike. Evasion means fooling the model at test time, once it's already trained. Poisoning means corrupting the training data itself. White-box versus black-box is about how much the attacker can see inside the model. And targeted versus transfer is whether the attack is aimed at one specific model, or built on one model and reused on another. In my project this maps perfectly: the homoglyph letter-swaps are evasion; the importance-guided attack is a targeted grey-box evasion, because it uses partial knowledge of my model's weights; the fake user reports are poisoning; and testing on DistilBERT is the transfer case. Top-right, character and tokenization attacks: the NLP-security lecture literally used examples like 'Get r1ch qu1ck' and a Cyrillic 'paypal', and explained how sub-word tokenizers — the way models like BERT chop words into pieces — break when you perturb the characters. That is exactly my attack and exactly my point about DistilBERT. Bottom-left, the defences: the lectures name two standard countermeasures — canonicalising, meaning normalising look-alikes back to plain letters, and adversarial training. I built both and measured them against each tier of attack. Bottom-right, anomaly detection: Isolation Forest, One-Class SVM and Mahalanobis distance from the abnormality lecture — methods that learn what 'normal' looks like and flag anything that doesn't fit — are my named next step, a separate detector that spots obfuscated mail as anomalous. And even my framing for the whole drift story comes from this course: my 2008 model is Taleb's turkey — fed every single day, and therefore totally confident, right up until Thanksgiving, when the assumption that the past predicts the future suddenly fails. That is the exact inductive trap the abnormality lecture warned about.</a:t>
             </a:r>
           </a:p>
-          <a:p/>
+          <a:p>
+            <a:endParaRPr/>
+          </a:p>
           <a:p>
             <a:r>
               <a:t>— — —  עברית  — — —</a:t>
             </a:r>
           </a:p>
-          <a:p/>
+          <a:p>
+            <a:endParaRPr/>
+          </a:p>
           <a:p>
             <a:r>
               <a:t>השקף הזה מראה שהמתקפות וההגנות הן לא דברים שהמצאתי — הם מגיעים ישירות מהטקסונומיה של הקורס עצמו, המסגרת שלימדו אותנו כדי לארגן למידת-מכונה יריבה. בואו נעבור עליו קופסה-קופסה. שמאל למעלה, טקסונומיית המתקפות: מתקפות מסווגות לפי מתי ואיך הן פוגעות. התחמקות (evasion) אומרת לרמות את המודל בזמן הבדיקה, אחרי שהוא כבר אומן. הרעלה (poisoning) אומרת לקלקל את נתוני האימון עצמם. קופסה-לבנה מול קופסה-שחורה זה כמה התוקף רואה בתוך המודל. וממוקד מול העברה (transfer) זה האם המתקפה מכוונת למודל ספציפי אחד, או נבנתה על מודל אחד ומשמשת שוב על אחר. בפרויקט שלי זה מתמפה בול: החלפות האותיות הומוגליף הן evasion; המתקפה מונחית-החשיבות היא evasion ממוקדת מסוג grey-box, כי היא משתמשת בידע חלקי על המשקלים של המודל שלי; הדיווחים המזויפים הם poisoning; והבדיקה על DistilBERT היא מקרה ה-transfer. ימין למעלה, מתקפות תווים וטוקניזציה: הרצאת אבטחת ה-NLP ממש השתמשה בדוגמאות כמו 'Get r1ch qu1ck' ו-'paypal' קירילי, והסבירה איך טוקנייזרים ברמת תת-מילה — האופן שבו מודלים כמו BERT מפרקים מילים לחתיכות — נשברים כשמשבשים את התווים. זו בדיוק המתקפה שלי ובדיוק הנקודה שלי לגבי DistilBERT. שמאל למטה, ההגנות: ההרצאות מנקבות בשם שתי הגנות סטנדרטיות — קנוניקליזציה, כלומר החזרת כפילויות לאותיות רגילות, ואימון יריב. בניתי את שתיהן ומדדתי אותן מול כל דרג של מתקפה. ימין למטה, זיהוי חריגות: Isolation Forest, One-Class SVM ומרחק מהלנוביס מהרצאת החריגוּת — שיטות שלומדות איך 'נורמלי' נראה ומסמנות כל דבר שלא מתאים — הן הצעד הבא שנקבתי בשמו, גלאי נפרד שמזהה דואר מעורפל כחריג. ואפילו המסגור של כל סיפור הדריפט מגיע מהקורס הזה: מודל 2008 שלי הוא תרנגול-ההודו של טאלב — מאכילים אותו כל יום, ולכן הוא בטוח לגמרי, עד יום ההודיה, כשההנחה שהעבר מנבא את העתיד נכשלת פתאום. זו בדיוק מלכודת ההיסק שהרצאת החריגוּת הזהירה מפניה.</a:t>
@@ -9386,91 +9424,13 @@
       </p:sp>
       <p:sp>
         <p:nvSpPr>
-          <p:cNvPr id="4" name="Text 2"/>
-          <p:cNvSpPr/>
-          <p:nvPr/>
-        </p:nvSpPr>
-        <p:spPr>
-          <a:xfrm>
-            <a:off x="566928" y="2194560"/>
-            <a:ext cx="10972800" cy="1097280"/>
-          </a:xfrm>
-          <a:prstGeom prst="rect">
-            <a:avLst/>
-          </a:prstGeom>
-          <a:noFill/>
-          <a:ln/>
-        </p:spPr>
-        <p:txBody>
-          <a:bodyPr wrap="square" rtlCol="0" anchor="ctr"/>
-          <a:lstStyle/>
-          <a:p>
-            <a:pPr marL="0" indent="0">
-              <a:buNone/>
-            </a:pPr>
-            <a:r>
-              <a:rPr lang="en-US" sz="4600" b="1" dirty="0">
-                <a:solidFill>
-                  <a:srgbClr val="FFFFFF"/>
-                </a:solidFill>
-                <a:latin typeface="Cambria" pitchFamily="34" charset="0"/>
-                <a:ea typeface="Cambria" pitchFamily="34" charset="-122"/>
-                <a:cs typeface="Cambria" pitchFamily="34" charset="-120"/>
-              </a:rPr>
-              <a:t>Now I attack my own model.</a:t>
-            </a:r>
-            <a:endParaRPr lang="en-US" sz="4600" dirty="0"/>
-          </a:p>
-        </p:txBody>
-      </p:sp>
-      <p:sp>
-        <p:nvSpPr>
-          <p:cNvPr id="5" name="Text 3"/>
-          <p:cNvSpPr/>
-          <p:nvPr/>
-        </p:nvSpPr>
-        <p:spPr>
-          <a:xfrm>
-            <a:off x="566928" y="3429000"/>
-            <a:ext cx="9875520" cy="1280160"/>
-          </a:xfrm>
-          <a:prstGeom prst="rect">
-            <a:avLst/>
-          </a:prstGeom>
-          <a:noFill/>
-          <a:ln/>
-        </p:spPr>
-        <p:txBody>
-          <a:bodyPr wrap="square" rtlCol="0" anchor="t"/>
-          <a:lstStyle/>
-          <a:p>
-            <a:pPr marL="0" indent="0">
-              <a:buNone/>
-            </a:pPr>
-            <a:r>
-              <a:rPr lang="en-US" sz="1800" dirty="0">
-                <a:solidFill>
-                  <a:srgbClr val="C7D3D9"/>
-                </a:solidFill>
-                <a:latin typeface="Calibri" pitchFamily="34" charset="0"/>
-                <a:ea typeface="Calibri" pitchFamily="34" charset="-122"/>
-                <a:cs typeface="Calibri" pitchFamily="34" charset="-120"/>
-              </a:rPr>
-              <a:t>Everything so far built a near-perfect detector. From here I switch sides and attack it the way a real adversary would — then fix each hole, and attack the fix. Each attack that follows is shown three ways: what the attack is, how I fixed it, and the result.</a:t>
-            </a:r>
-            <a:endParaRPr lang="en-US" sz="1800" dirty="0"/>
-          </a:p>
-        </p:txBody>
-      </p:sp>
-      <p:sp>
-        <p:nvSpPr>
           <p:cNvPr id="6" name="Shape 4"/>
           <p:cNvSpPr/>
           <p:nvPr/>
         </p:nvSpPr>
         <p:spPr>
           <a:xfrm>
-            <a:off x="566928" y="4846320"/>
+            <a:off x="2944368" y="3383280"/>
             <a:ext cx="1554480" cy="548640"/>
           </a:xfrm>
           <a:prstGeom prst="roundRect">
@@ -9504,7 +9464,7 @@
         </p:nvSpPr>
         <p:spPr>
           <a:xfrm>
-            <a:off x="566928" y="4846320"/>
+            <a:off x="2944368" y="3383280"/>
             <a:ext cx="1554480" cy="548640"/>
           </a:xfrm>
           <a:prstGeom prst="rect">
@@ -9543,7 +9503,7 @@
         </p:nvSpPr>
         <p:spPr>
           <a:xfrm>
-            <a:off x="2395728" y="4892040"/>
+            <a:off x="4773168" y="3429000"/>
             <a:ext cx="457200" cy="457200"/>
           </a:xfrm>
           <a:prstGeom prst="rect">
@@ -9582,7 +9542,7 @@
         </p:nvSpPr>
         <p:spPr>
           <a:xfrm>
-            <a:off x="2944368" y="4846320"/>
+            <a:off x="5321808" y="3383280"/>
             <a:ext cx="1554480" cy="548640"/>
           </a:xfrm>
           <a:prstGeom prst="roundRect">
@@ -9616,7 +9576,7 @@
         </p:nvSpPr>
         <p:spPr>
           <a:xfrm>
-            <a:off x="2944368" y="4846320"/>
+            <a:off x="5321808" y="3383280"/>
             <a:ext cx="1554480" cy="548640"/>
           </a:xfrm>
           <a:prstGeom prst="rect">
@@ -9655,7 +9615,7 @@
         </p:nvSpPr>
         <p:spPr>
           <a:xfrm>
-            <a:off x="4773168" y="4892040"/>
+            <a:off x="7150608" y="3429000"/>
             <a:ext cx="457200" cy="457200"/>
           </a:xfrm>
           <a:prstGeom prst="rect">
@@ -9694,7 +9654,7 @@
         </p:nvSpPr>
         <p:spPr>
           <a:xfrm>
-            <a:off x="5321808" y="4846320"/>
+            <a:off x="7699248" y="3383280"/>
             <a:ext cx="1554480" cy="548640"/>
           </a:xfrm>
           <a:prstGeom prst="roundRect">
@@ -9728,7 +9688,7 @@
         </p:nvSpPr>
         <p:spPr>
           <a:xfrm>
-            <a:off x="5321808" y="4846320"/>
+            <a:off x="7699248" y="3383280"/>
             <a:ext cx="1554480" cy="548640"/>
           </a:xfrm>
           <a:prstGeom prst="rect">
@@ -11149,8 +11109,8 @@
         </p:nvSpPr>
         <p:spPr>
           <a:xfrm>
-            <a:off x="731520" y="5715000"/>
-            <a:ext cx="5852160" cy="274320"/>
+            <a:off x="731520" y="5687568"/>
+            <a:ext cx="5852160" cy="658368"/>
           </a:xfrm>
           <a:prstGeom prst="rect">
             <a:avLst/>
@@ -11166,17 +11126,27 @@
               <a:buNone/>
             </a:pPr>
             <a:r>
-              <a:rPr lang="en-US" sz="1100" i="1" dirty="0">
+              <a:rPr sz="1100" b="1" i="0">
+                <a:solidFill>
+                  <a:srgbClr val="EAF0F1"/>
+                </a:solidFill>
+                <a:latin typeface="Calibri"/>
+              </a:rPr>
+              <a:t>budget = 8 edits  =  Levenshtein (edit) distance 8</a:t>
+            </a:r>
+            <a:endParaRPr lang="en-US" sz="1100" dirty="0"/>
+          </a:p>
+          <a:p>
+            <a:pPr algn="ctr"/>
+            <a:r>
+              <a:rPr sz="950" b="0" i="1">
                 <a:solidFill>
                   <a:srgbClr val="95A6AD"/>
                 </a:solidFill>
-                <a:latin typeface="Calibri" pitchFamily="34" charset="0"/>
-                <a:ea typeface="Calibri" pitchFamily="34" charset="-122"/>
-                <a:cs typeface="Calibri" pitchFamily="34" charset="-120"/>
-              </a:rPr>
-              <a:t>same budget (8 edits) — targeting matters</a:t>
-            </a:r>
-            <a:endParaRPr lang="en-US" sz="1100" dirty="0"/>
+                <a:latin typeface="Calibri"/>
+              </a:rPr>
+              <a:t>Levenshtein = fewest single-character insert / delete / substitute steps to change one text into another</a:t>
+            </a:r>
           </a:p>
         </p:txBody>
       </p:sp>
@@ -12486,7 +12456,13 @@
         <p:nvGraphicFramePr>
           <p:cNvPr id="6" name="Chart 0"/>
           <p:cNvGraphicFramePr/>
-          <p:nvPr/>
+          <p:nvPr>
+            <p:extLst>
+              <p:ext uri="{D42A27DB-BD31-4B8C-83A1-F6EECF244321}">
+                <p14:modId xmlns:p14="http://schemas.microsoft.com/office/powerpoint/2010/main" val="316597908"/>
+              </p:ext>
+            </p:extLst>
+          </p:nvPr>
         </p:nvGraphicFramePr>
         <p:xfrm>
           <a:off x="731520" y="1920240"/>
@@ -12695,103 +12671,6 @@
               <a:t>two attack classes now closed by proof: letters, and word-insertion</a:t>
             </a:r>
             <a:endParaRPr lang="en-US" sz="950" dirty="0"/>
-          </a:p>
-        </p:txBody>
-      </p:sp>
-      <p:sp>
-        <p:nvSpPr>
-          <p:cNvPr id="10" name="TextBox 9"/>
-          <p:cNvSpPr txBox="1"/>
-          <p:nvPr/>
-        </p:nvSpPr>
-        <p:spPr>
-          <a:xfrm>
-            <a:off x="731520" y="5806440"/>
-            <a:ext cx="5852160" cy="566928"/>
-          </a:xfrm>
-          <a:prstGeom prst="rect">
-            <a:avLst/>
-          </a:prstGeom>
-          <a:noFill/>
-        </p:spPr>
-        <p:txBody>
-          <a:bodyPr wrap="square">
-            <a:spAutoFit/>
-          </a:bodyPr>
-          <a:lstStyle/>
-          <a:p>
-            <a:r>
-              <a:rPr sz="1050" b="1" i="0">
-                <a:solidFill>
-                  <a:srgbClr val="E97A60"/>
-                </a:solidFill>
-                <a:latin typeface="Calibri"/>
-              </a:rPr>
-              <a:t>standard</a:t>
-            </a:r>
-            <a:r>
-              <a:rPr sz="1050" b="0" i="0">
-                <a:solidFill>
-                  <a:srgbClr val="95A6AD"/>
-                </a:solidFill>
-                <a:latin typeface="Calibri"/>
-              </a:rPr>
-              <a:t> = normal model · </a:t>
-            </a:r>
-            <a:r>
-              <a:rPr sz="1050" b="1" i="0">
-                <a:solidFill>
-                  <a:srgbClr val="3CB6A6"/>
-                </a:solidFill>
-                <a:latin typeface="Calibri"/>
-              </a:rPr>
-              <a:t>one-way</a:t>
-            </a:r>
-            <a:r>
-              <a:rPr sz="1050" b="0" i="0">
-                <a:solidFill>
-                  <a:srgbClr val="95A6AD"/>
-                </a:solidFill>
-                <a:latin typeface="Calibri"/>
-              </a:rPr>
-              <a:t> = monotone safety-net.   </a:t>
-            </a:r>
-            <a:r>
-              <a:rPr sz="1050" b="1" i="0">
-                <a:solidFill>
-                  <a:srgbClr val="EAF0F1"/>
-                </a:solidFill>
-                <a:latin typeface="Calibri"/>
-              </a:rPr>
-              <a:t>‘diluted’</a:t>
-            </a:r>
-            <a:r>
-              <a:rPr sz="1050" b="0" i="0">
-                <a:solidFill>
-                  <a:srgbClr val="95A6AD"/>
-                </a:solidFill>
-                <a:latin typeface="Calibri"/>
-              </a:rPr>
-              <a:t> = under the padding attack · </a:t>
-            </a:r>
-            <a:r>
-              <a:rPr sz="1050" b="1" i="0">
-                <a:solidFill>
-                  <a:srgbClr val="EAF0F1"/>
-                </a:solidFill>
-                <a:latin typeface="Calibri"/>
-              </a:rPr>
-              <a:t>‘clean F1’</a:t>
-            </a:r>
-            <a:r>
-              <a:rPr sz="1050" b="0" i="0">
-                <a:solidFill>
-                  <a:srgbClr val="95A6AD"/>
-                </a:solidFill>
-                <a:latin typeface="Calibri"/>
-              </a:rPr>
-              <a:t> = score on normal mail.</a:t>
-            </a:r>
           </a:p>
         </p:txBody>
       </p:sp>
@@ -19241,19 +19120,26 @@
           <a:bodyPr wrap="square" rtlCol="0" anchor="t"/>
           <a:lstStyle/>
           <a:p>
-            <a:pPr marL="0" indent="0">
-              <a:buNone/>
-            </a:pPr>
-            <a:r>
-              <a:rPr lang="en-US" sz="1200" i="1" dirty="0">
+            <a:pPr marL="0" indent="0" algn="l">
+              <a:buNone/>
+            </a:pPr>
+            <a:r>
+              <a:rPr sz="1200" b="1" i="0">
+                <a:solidFill>
+                  <a:srgbClr val="D4AB4E"/>
+                </a:solidFill>
+                <a:latin typeface="Calibri"/>
+              </a:rPr>
+              <a:t>Also considered — a hand-crafted emotion feature:  </a:t>
+            </a:r>
+            <a:r>
+              <a:rPr sz="1200" b="0" i="1">
                 <a:solidFill>
                   <a:srgbClr val="95A6AD"/>
                 </a:solidFill>
-                <a:latin typeface="Calibri" pitchFamily="34" charset="0"/>
-                <a:ea typeface="Calibri" pitchFamily="34" charset="-122"/>
-                <a:cs typeface="Calibri" pitchFamily="34" charset="-120"/>
-              </a:rPr>
-              <a:t>Caveats stated: N is small; attacker and judge share a model family; outputs are frozen and committed for reproducibility.</a:t>
+                <a:latin typeface="Calibri"/>
+              </a:rPr>
+              <a:t>use an LLM (or a cheap VADER-style lexicon) to score urgency / fear / reward cues as an extra phishing signal. Likely overlaps with TF-IDF, so kept as future work — best aimed at urgency, not raw positive/negative.</a:t>
             </a:r>
             <a:endParaRPr lang="en-US" sz="1200" dirty="0"/>
           </a:p>

</xml_diff>